<commit_message>
PowerPoint final : prenom equipe, captures demo integrees (slide 10), URL repo
Co-Authored-By: Claude Opus 4.8 <noreply@anthropic.com>
</commit_message>
<xml_diff>
--- a/presentation/K8s-ECommerce-Presentation.pptx
+++ b/presentation/K8s-ECommerce-Presentation.pptx
@@ -2332,7 +2332,7 @@
                 <a:ea typeface="Calibri" pitchFamily="34" charset="-122"/>
                 <a:cs typeface="Calibri" pitchFamily="34" charset="-120"/>
               </a:rPr>
-              <a:t>[Membre 1]  |  [Membre 2]  |  [Membre 3]</a:t>
+              <a:t>Abderahmane</a:t>
             </a:r>
             <a:endParaRPr lang="en-US" sz="1400" dirty="0"/>
           </a:p>
@@ -2535,8 +2535,8 @@
         </p:nvSpPr>
         <p:spPr>
           <a:xfrm>
-            <a:off x="548640" y="1417320"/>
-            <a:ext cx="5440680" cy="1234440"/>
+            <a:off x="457200" y="1280160"/>
+            <a:ext cx="5632704" cy="3840480"/>
           </a:xfrm>
           <a:prstGeom prst="rect">
             <a:avLst/>
@@ -2561,34 +2561,14 @@
       </p:sp>
       <p:sp>
         <p:nvSpPr>
-          <p:cNvPr id="7" name="Shape 5"/>
-          <p:cNvSpPr/>
-          <p:nvPr/>
-        </p:nvSpPr>
-        <p:spPr>
-          <a:xfrm>
-            <a:off x="777240" y="1709928"/>
-            <a:ext cx="640080" cy="640080"/>
-          </a:xfrm>
-          <a:prstGeom prst="ellipse">
-            <a:avLst/>
-          </a:prstGeom>
-          <a:solidFill>
-            <a:srgbClr val="326CE5"/>
-          </a:solidFill>
-          <a:ln/>
-        </p:spPr>
-      </p:sp>
-      <p:sp>
-        <p:nvSpPr>
-          <p:cNvPr id="8" name="Text 6"/>
-          <p:cNvSpPr/>
-          <p:nvPr/>
-        </p:nvSpPr>
-        <p:spPr>
-          <a:xfrm>
-            <a:off x="777240" y="1709928"/>
-            <a:ext cx="640080" cy="640080"/>
+          <p:cNvPr id="7" name="Text 5"/>
+          <p:cNvSpPr/>
+          <p:nvPr/>
+        </p:nvSpPr>
+        <p:spPr>
+          <a:xfrm>
+            <a:off x="658368" y="1371600"/>
+            <a:ext cx="5212080" cy="292608"/>
           </a:xfrm>
           <a:prstGeom prst="rect">
             <a:avLst/>
@@ -2600,34 +2580,57 @@
           <a:bodyPr wrap="square" rtlCol="0" anchor="ctr"/>
           <a:lstStyle/>
           <a:p>
-            <a:pPr algn="ctr" indent="0" marL="0">
-              <a:buNone/>
-            </a:pPr>
-            <a:r>
-              <a:rPr lang="en-US" sz="2400" b="1" dirty="0">
-                <a:solidFill>
-                  <a:srgbClr val="FFFFFF"/>
+            <a:pPr indent="0" marL="0">
+              <a:buNone/>
+            </a:pPr>
+            <a:r>
+              <a:rPr lang="en-US" sz="1350" b="1" dirty="0">
+                <a:solidFill>
+                  <a:srgbClr val="326CE5"/>
                 </a:solidFill>
                 <a:latin typeface="Trebuchet MS" pitchFamily="34" charset="0"/>
                 <a:ea typeface="Trebuchet MS" pitchFamily="34" charset="-122"/>
                 <a:cs typeface="Trebuchet MS" pitchFamily="34" charset="-120"/>
               </a:rPr>
-              <a:t>A</a:t>
-            </a:r>
-            <a:endParaRPr lang="en-US" sz="2400" dirty="0"/>
-          </a:p>
-        </p:txBody>
-      </p:sp>
-      <p:sp>
-        <p:nvSpPr>
-          <p:cNvPr id="9" name="Text 7"/>
-          <p:cNvSpPr/>
-          <p:nvPr/>
-        </p:nvSpPr>
-        <p:spPr>
-          <a:xfrm>
-            <a:off x="1600200" y="1618488"/>
-            <a:ext cx="4206240" cy="411480"/>
+              <a:t>Application e-commerce (Frontend)</a:t>
+            </a:r>
+            <a:endParaRPr lang="en-US" sz="1350" dirty="0"/>
+          </a:p>
+        </p:txBody>
+      </p:sp>
+      <p:pic>
+        <p:nvPicPr>
+          <p:cNvPr id="8" name="Image 0" descr="docs/screenshots/01-app-frontend.png">    </p:cNvPr>
+          <p:cNvPicPr>
+            <a:picLocks noChangeAspect="1"/>
+          </p:cNvPicPr>
+          <p:nvPr/>
+        </p:nvPicPr>
+        <p:blipFill>
+          <a:blip r:embed="rId1"/>
+          <a:srcRect l="0" r="0" t="0" b="0"/>
+          <a:stretch/>
+        </p:blipFill>
+        <p:spPr>
+          <a:xfrm>
+            <a:off x="658368" y="1737360"/>
+            <a:ext cx="5212080" cy="2926080"/>
+          </a:xfrm>
+          <a:prstGeom prst="rect">
+            <a:avLst/>
+          </a:prstGeom>
+        </p:spPr>
+      </p:pic>
+      <p:sp>
+        <p:nvSpPr>
+          <p:cNvPr id="9" name="Text 6"/>
+          <p:cNvSpPr/>
+          <p:nvPr/>
+        </p:nvSpPr>
+        <p:spPr>
+          <a:xfrm>
+            <a:off x="658368" y="4736592"/>
+            <a:ext cx="5212080" cy="320040"/>
           </a:xfrm>
           <a:prstGeom prst="rect">
             <a:avLst/>
@@ -2643,69 +2646,30 @@
               <a:buNone/>
             </a:pPr>
             <a:r>
-              <a:rPr lang="en-US" sz="1500" b="1" dirty="0">
-                <a:solidFill>
-                  <a:srgbClr val="1A2233"/>
-                </a:solidFill>
-                <a:latin typeface="Trebuchet MS" pitchFamily="34" charset="0"/>
-                <a:ea typeface="Trebuchet MS" pitchFamily="34" charset="-122"/>
-                <a:cs typeface="Trebuchet MS" pitchFamily="34" charset="-120"/>
-              </a:rPr>
-              <a:t>Frontend accessible</a:t>
-            </a:r>
-            <a:endParaRPr lang="en-US" sz="1500" dirty="0"/>
-          </a:p>
-        </p:txBody>
-      </p:sp>
-      <p:sp>
-        <p:nvSpPr>
-          <p:cNvPr id="10" name="Text 8"/>
-          <p:cNvSpPr/>
-          <p:nvPr/>
-        </p:nvSpPr>
-        <p:spPr>
-          <a:xfrm>
-            <a:off x="1600200" y="2020824"/>
-            <a:ext cx="4251960" cy="502920"/>
-          </a:xfrm>
-          <a:prstGeom prst="rect">
-            <a:avLst/>
-          </a:prstGeom>
-          <a:noFill/>
-          <a:ln/>
-        </p:spPr>
-        <p:txBody>
-          <a:bodyPr wrap="square" rtlCol="0" anchor="ctr"/>
-          <a:lstStyle/>
-          <a:p>
-            <a:pPr indent="0" marL="0">
-              <a:buNone/>
-            </a:pPr>
-            <a:r>
-              <a:rPr lang="en-US" sz="1050" dirty="0">
+              <a:rPr lang="en-US" sz="950" i="1" dirty="0">
                 <a:solidFill>
                   <a:srgbClr val="5B6B7F"/>
                 </a:solidFill>
-                <a:latin typeface="Consolas" pitchFamily="34" charset="0"/>
-                <a:ea typeface="Consolas" pitchFamily="34" charset="-122"/>
-                <a:cs typeface="Consolas" pitchFamily="34" charset="-120"/>
-              </a:rPr>
-              <a:t>curl localhost:30080/healthz  -&gt;  ok</a:t>
-            </a:r>
-            <a:endParaRPr lang="en-US" sz="1050" dirty="0"/>
-          </a:p>
-        </p:txBody>
-      </p:sp>
-      <p:sp>
-        <p:nvSpPr>
-          <p:cNvPr id="11" name="Shape 9"/>
-          <p:cNvSpPr/>
-          <p:nvPr/>
-        </p:nvSpPr>
-        <p:spPr>
-          <a:xfrm>
-            <a:off x="6172200" y="1417320"/>
-            <a:ext cx="5440680" cy="1234440"/>
+                <a:latin typeface="Calibri" pitchFamily="34" charset="0"/>
+                <a:ea typeface="Calibri" pitchFamily="34" charset="-122"/>
+                <a:cs typeface="Calibri" pitchFamily="34" charset="-120"/>
+              </a:rPr>
+              <a:t>localhost:30080 - catalogue servi par le backend via MongoDB</a:t>
+            </a:r>
+            <a:endParaRPr lang="en-US" sz="950" dirty="0"/>
+          </a:p>
+        </p:txBody>
+      </p:sp>
+      <p:sp>
+        <p:nvSpPr>
+          <p:cNvPr id="10" name="Shape 7"/>
+          <p:cNvSpPr/>
+          <p:nvPr/>
+        </p:nvSpPr>
+        <p:spPr>
+          <a:xfrm>
+            <a:off x="6254496" y="1280160"/>
+            <a:ext cx="5477256" cy="3840480"/>
           </a:xfrm>
           <a:prstGeom prst="rect">
             <a:avLst/>
@@ -2730,34 +2694,14 @@
       </p:sp>
       <p:sp>
         <p:nvSpPr>
-          <p:cNvPr id="12" name="Shape 10"/>
-          <p:cNvSpPr/>
-          <p:nvPr/>
-        </p:nvSpPr>
-        <p:spPr>
-          <a:xfrm>
-            <a:off x="6400800" y="1709928"/>
-            <a:ext cx="640080" cy="640080"/>
-          </a:xfrm>
-          <a:prstGeom prst="ellipse">
-            <a:avLst/>
-          </a:prstGeom>
-          <a:solidFill>
-            <a:srgbClr val="00B4D8"/>
-          </a:solidFill>
-          <a:ln/>
-        </p:spPr>
-      </p:sp>
-      <p:sp>
-        <p:nvSpPr>
-          <p:cNvPr id="13" name="Text 11"/>
-          <p:cNvSpPr/>
-          <p:nvPr/>
-        </p:nvSpPr>
-        <p:spPr>
-          <a:xfrm>
-            <a:off x="6400800" y="1709928"/>
-            <a:ext cx="640080" cy="640080"/>
+          <p:cNvPr id="11" name="Text 8"/>
+          <p:cNvSpPr/>
+          <p:nvPr/>
+        </p:nvSpPr>
+        <p:spPr>
+          <a:xfrm>
+            <a:off x="6455664" y="1371600"/>
+            <a:ext cx="5029200" cy="292608"/>
           </a:xfrm>
           <a:prstGeom prst="rect">
             <a:avLst/>
@@ -2769,34 +2713,57 @@
           <a:bodyPr wrap="square" rtlCol="0" anchor="ctr"/>
           <a:lstStyle/>
           <a:p>
-            <a:pPr algn="ctr" indent="0" marL="0">
-              <a:buNone/>
-            </a:pPr>
-            <a:r>
-              <a:rPr lang="en-US" sz="2400" b="1" dirty="0">
-                <a:solidFill>
-                  <a:srgbClr val="FFFFFF"/>
+            <a:pPr indent="0" marL="0">
+              <a:buNone/>
+            </a:pPr>
+            <a:r>
+              <a:rPr lang="en-US" sz="1350" b="1" dirty="0">
+                <a:solidFill>
+                  <a:srgbClr val="326CE5"/>
                 </a:solidFill>
                 <a:latin typeface="Trebuchet MS" pitchFamily="34" charset="0"/>
                 <a:ea typeface="Trebuchet MS" pitchFamily="34" charset="-122"/>
                 <a:cs typeface="Trebuchet MS" pitchFamily="34" charset="-120"/>
               </a:rPr>
-              <a:t>B</a:t>
-            </a:r>
-            <a:endParaRPr lang="en-US" sz="2400" dirty="0"/>
-          </a:p>
-        </p:txBody>
-      </p:sp>
-      <p:sp>
-        <p:nvSpPr>
-          <p:cNvPr id="14" name="Text 12"/>
-          <p:cNvSpPr/>
-          <p:nvPr/>
-        </p:nvSpPr>
-        <p:spPr>
-          <a:xfrm>
-            <a:off x="7223760" y="1618488"/>
-            <a:ext cx="4206240" cy="411480"/>
+              <a:t>Etat du cluster Kubernetes</a:t>
+            </a:r>
+            <a:endParaRPr lang="en-US" sz="1350" dirty="0"/>
+          </a:p>
+        </p:txBody>
+      </p:sp>
+      <p:pic>
+        <p:nvPicPr>
+          <p:cNvPr id="12" name="Image 1" descr="docs/screenshots/02-kubernetes-proof.png">    </p:cNvPr>
+          <p:cNvPicPr>
+            <a:picLocks noChangeAspect="1"/>
+          </p:cNvPicPr>
+          <p:nvPr/>
+        </p:nvPicPr>
+        <p:blipFill>
+          <a:blip r:embed="rId2"/>
+          <a:srcRect l="0" r="0" t="0" b="0"/>
+          <a:stretch/>
+        </p:blipFill>
+        <p:spPr>
+          <a:xfrm>
+            <a:off x="6455664" y="1737360"/>
+            <a:ext cx="5074920" cy="2926080"/>
+          </a:xfrm>
+          <a:prstGeom prst="rect">
+            <a:avLst/>
+          </a:prstGeom>
+        </p:spPr>
+      </p:pic>
+      <p:sp>
+        <p:nvSpPr>
+          <p:cNvPr id="13" name="Text 9"/>
+          <p:cNvSpPr/>
+          <p:nvPr/>
+        </p:nvSpPr>
+        <p:spPr>
+          <a:xfrm>
+            <a:off x="6455664" y="4736592"/>
+            <a:ext cx="5074920" cy="320040"/>
           </a:xfrm>
           <a:prstGeom prst="rect">
             <a:avLst/>
@@ -2812,407 +2779,30 @@
               <a:buNone/>
             </a:pPr>
             <a:r>
-              <a:rPr lang="en-US" sz="1500" b="1" dirty="0">
-                <a:solidFill>
-                  <a:srgbClr val="1A2233"/>
-                </a:solidFill>
-                <a:latin typeface="Trebuchet MS" pitchFamily="34" charset="0"/>
-                <a:ea typeface="Trebuchet MS" pitchFamily="34" charset="-122"/>
-                <a:cs typeface="Trebuchet MS" pitchFamily="34" charset="-120"/>
-              </a:rPr>
-              <a:t>Frontend  -&gt;  Backend</a:t>
-            </a:r>
-            <a:endParaRPr lang="en-US" sz="1500" dirty="0"/>
-          </a:p>
-        </p:txBody>
-      </p:sp>
-      <p:sp>
-        <p:nvSpPr>
-          <p:cNvPr id="15" name="Text 13"/>
-          <p:cNvSpPr/>
-          <p:nvPr/>
-        </p:nvSpPr>
-        <p:spPr>
-          <a:xfrm>
-            <a:off x="7223760" y="2020824"/>
-            <a:ext cx="4251960" cy="502920"/>
-          </a:xfrm>
-          <a:prstGeom prst="rect">
-            <a:avLst/>
-          </a:prstGeom>
-          <a:noFill/>
-          <a:ln/>
-        </p:spPr>
-        <p:txBody>
-          <a:bodyPr wrap="square" rtlCol="0" anchor="ctr"/>
-          <a:lstStyle/>
-          <a:p>
-            <a:pPr indent="0" marL="0">
-              <a:buNone/>
-            </a:pPr>
-            <a:r>
-              <a:rPr lang="en-US" sz="1050" dirty="0">
+              <a:rPr lang="en-US" sz="950" i="1" dirty="0">
                 <a:solidFill>
                   <a:srgbClr val="5B6B7F"/>
                 </a:solidFill>
-                <a:latin typeface="Consolas" pitchFamily="34" charset="0"/>
-                <a:ea typeface="Consolas" pitchFamily="34" charset="-122"/>
-                <a:cs typeface="Consolas" pitchFamily="34" charset="-120"/>
-              </a:rPr>
-              <a:t>GET /api/products  -&gt;  liste JSON des produits</a:t>
-            </a:r>
-            <a:endParaRPr lang="en-US" sz="1050" dirty="0"/>
-          </a:p>
-        </p:txBody>
-      </p:sp>
-      <p:sp>
-        <p:nvSpPr>
-          <p:cNvPr id="16" name="Shape 14"/>
-          <p:cNvSpPr/>
-          <p:nvPr/>
-        </p:nvSpPr>
-        <p:spPr>
-          <a:xfrm>
-            <a:off x="548640" y="2834640"/>
-            <a:ext cx="5440680" cy="1234440"/>
-          </a:xfrm>
-          <a:prstGeom prst="rect">
-            <a:avLst/>
-          </a:prstGeom>
-          <a:solidFill>
-            <a:srgbClr val="FFFFFF"/>
-          </a:solidFill>
-          <a:ln w="12700">
-            <a:solidFill>
-              <a:srgbClr val="DDE3EC"/>
-            </a:solidFill>
-            <a:prstDash val="solid"/>
-          </a:ln>
-          <a:effectLst>
-            <a:outerShdw sx="100000" sy="100000" kx="0" ky="0" algn="bl" rotWithShape="0" blurRad="101600" dist="38100" dir="8100000">
-              <a:srgbClr val="000000">
-                <a:alpha val="16000"/>
-              </a:srgbClr>
-            </a:outerShdw>
-          </a:effectLst>
-        </p:spPr>
-      </p:sp>
-      <p:sp>
-        <p:nvSpPr>
-          <p:cNvPr id="17" name="Shape 15"/>
-          <p:cNvSpPr/>
-          <p:nvPr/>
-        </p:nvSpPr>
-        <p:spPr>
-          <a:xfrm>
-            <a:off x="777240" y="3127248"/>
-            <a:ext cx="640080" cy="640080"/>
-          </a:xfrm>
-          <a:prstGeom prst="ellipse">
-            <a:avLst/>
-          </a:prstGeom>
-          <a:solidFill>
-            <a:srgbClr val="326CE5"/>
-          </a:solidFill>
-          <a:ln/>
-        </p:spPr>
-      </p:sp>
-      <p:sp>
-        <p:nvSpPr>
-          <p:cNvPr id="18" name="Text 16"/>
-          <p:cNvSpPr/>
-          <p:nvPr/>
-        </p:nvSpPr>
-        <p:spPr>
-          <a:xfrm>
-            <a:off x="777240" y="3127248"/>
-            <a:ext cx="640080" cy="640080"/>
-          </a:xfrm>
-          <a:prstGeom prst="rect">
-            <a:avLst/>
-          </a:prstGeom>
-          <a:noFill/>
-          <a:ln/>
-        </p:spPr>
-        <p:txBody>
-          <a:bodyPr wrap="square" rtlCol="0" anchor="ctr"/>
-          <a:lstStyle/>
-          <a:p>
-            <a:pPr algn="ctr" indent="0" marL="0">
-              <a:buNone/>
-            </a:pPr>
-            <a:r>
-              <a:rPr lang="en-US" sz="2400" b="1" dirty="0">
-                <a:solidFill>
-                  <a:srgbClr val="FFFFFF"/>
-                </a:solidFill>
-                <a:latin typeface="Trebuchet MS" pitchFamily="34" charset="0"/>
-                <a:ea typeface="Trebuchet MS" pitchFamily="34" charset="-122"/>
-                <a:cs typeface="Trebuchet MS" pitchFamily="34" charset="-120"/>
-              </a:rPr>
-              <a:t>C</a:t>
-            </a:r>
-            <a:endParaRPr lang="en-US" sz="2400" dirty="0"/>
-          </a:p>
-        </p:txBody>
-      </p:sp>
-      <p:sp>
-        <p:nvSpPr>
-          <p:cNvPr id="19" name="Text 17"/>
-          <p:cNvSpPr/>
-          <p:nvPr/>
-        </p:nvSpPr>
-        <p:spPr>
-          <a:xfrm>
-            <a:off x="1600200" y="3035808"/>
-            <a:ext cx="4206240" cy="411480"/>
-          </a:xfrm>
-          <a:prstGeom prst="rect">
-            <a:avLst/>
-          </a:prstGeom>
-          <a:noFill/>
-          <a:ln/>
-        </p:spPr>
-        <p:txBody>
-          <a:bodyPr wrap="square" rtlCol="0" anchor="ctr"/>
-          <a:lstStyle/>
-          <a:p>
-            <a:pPr indent="0" marL="0">
-              <a:buNone/>
-            </a:pPr>
-            <a:r>
-              <a:rPr lang="en-US" sz="1500" b="1" dirty="0">
-                <a:solidFill>
-                  <a:srgbClr val="1A2233"/>
-                </a:solidFill>
-                <a:latin typeface="Trebuchet MS" pitchFamily="34" charset="0"/>
-                <a:ea typeface="Trebuchet MS" pitchFamily="34" charset="-122"/>
-                <a:cs typeface="Trebuchet MS" pitchFamily="34" charset="-120"/>
-              </a:rPr>
-              <a:t>Backend  -&gt;  MongoDB</a:t>
-            </a:r>
-            <a:endParaRPr lang="en-US" sz="1500" dirty="0"/>
-          </a:p>
-        </p:txBody>
-      </p:sp>
-      <p:sp>
-        <p:nvSpPr>
-          <p:cNvPr id="20" name="Text 18"/>
-          <p:cNvSpPr/>
-          <p:nvPr/>
-        </p:nvSpPr>
-        <p:spPr>
-          <a:xfrm>
-            <a:off x="1600200" y="3438144"/>
-            <a:ext cx="4251960" cy="502920"/>
-          </a:xfrm>
-          <a:prstGeom prst="rect">
-            <a:avLst/>
-          </a:prstGeom>
-          <a:noFill/>
-          <a:ln/>
-        </p:spPr>
-        <p:txBody>
-          <a:bodyPr wrap="square" rtlCol="0" anchor="ctr"/>
-          <a:lstStyle/>
-          <a:p>
-            <a:pPr indent="0" marL="0">
-              <a:buNone/>
-            </a:pPr>
-            <a:r>
-              <a:rPr lang="en-US" sz="1050" dirty="0">
-                <a:solidFill>
-                  <a:srgbClr val="5B6B7F"/>
-                </a:solidFill>
-                <a:latin typeface="Consolas" pitchFamily="34" charset="0"/>
-                <a:ea typeface="Consolas" pitchFamily="34" charset="-122"/>
-                <a:cs typeface="Consolas" pitchFamily="34" charset="-120"/>
-              </a:rPr>
-              <a:t>/api/health  -&gt;  {"db":"connected"}</a:t>
-            </a:r>
-            <a:endParaRPr lang="en-US" sz="1050" dirty="0"/>
-          </a:p>
-        </p:txBody>
-      </p:sp>
-      <p:sp>
-        <p:nvSpPr>
-          <p:cNvPr id="21" name="Shape 19"/>
-          <p:cNvSpPr/>
-          <p:nvPr/>
-        </p:nvSpPr>
-        <p:spPr>
-          <a:xfrm>
-            <a:off x="6172200" y="2834640"/>
-            <a:ext cx="5440680" cy="1234440"/>
-          </a:xfrm>
-          <a:prstGeom prst="rect">
-            <a:avLst/>
-          </a:prstGeom>
-          <a:solidFill>
-            <a:srgbClr val="FFFFFF"/>
-          </a:solidFill>
-          <a:ln w="12700">
-            <a:solidFill>
-              <a:srgbClr val="DDE3EC"/>
-            </a:solidFill>
-            <a:prstDash val="solid"/>
-          </a:ln>
-          <a:effectLst>
-            <a:outerShdw sx="100000" sy="100000" kx="0" ky="0" algn="bl" rotWithShape="0" blurRad="101600" dist="38100" dir="8100000">
-              <a:srgbClr val="000000">
-                <a:alpha val="16000"/>
-              </a:srgbClr>
-            </a:outerShdw>
-          </a:effectLst>
-        </p:spPr>
-      </p:sp>
-      <p:sp>
-        <p:nvSpPr>
-          <p:cNvPr id="22" name="Shape 20"/>
-          <p:cNvSpPr/>
-          <p:nvPr/>
-        </p:nvSpPr>
-        <p:spPr>
-          <a:xfrm>
-            <a:off x="6400800" y="3127248"/>
-            <a:ext cx="640080" cy="640080"/>
-          </a:xfrm>
-          <a:prstGeom prst="ellipse">
-            <a:avLst/>
-          </a:prstGeom>
-          <a:solidFill>
-            <a:srgbClr val="00B4D8"/>
-          </a:solidFill>
-          <a:ln/>
-        </p:spPr>
-      </p:sp>
-      <p:sp>
-        <p:nvSpPr>
-          <p:cNvPr id="23" name="Text 21"/>
-          <p:cNvSpPr/>
-          <p:nvPr/>
-        </p:nvSpPr>
-        <p:spPr>
-          <a:xfrm>
-            <a:off x="6400800" y="3127248"/>
-            <a:ext cx="640080" cy="640080"/>
-          </a:xfrm>
-          <a:prstGeom prst="rect">
-            <a:avLst/>
-          </a:prstGeom>
-          <a:noFill/>
-          <a:ln/>
-        </p:spPr>
-        <p:txBody>
-          <a:bodyPr wrap="square" rtlCol="0" anchor="ctr"/>
-          <a:lstStyle/>
-          <a:p>
-            <a:pPr algn="ctr" indent="0" marL="0">
-              <a:buNone/>
-            </a:pPr>
-            <a:r>
-              <a:rPr lang="en-US" sz="2400" b="1" dirty="0">
-                <a:solidFill>
-                  <a:srgbClr val="FFFFFF"/>
-                </a:solidFill>
-                <a:latin typeface="Trebuchet MS" pitchFamily="34" charset="0"/>
-                <a:ea typeface="Trebuchet MS" pitchFamily="34" charset="-122"/>
-                <a:cs typeface="Trebuchet MS" pitchFamily="34" charset="-120"/>
-              </a:rPr>
-              <a:t>D</a:t>
-            </a:r>
-            <a:endParaRPr lang="en-US" sz="2400" dirty="0"/>
-          </a:p>
-        </p:txBody>
-      </p:sp>
-      <p:sp>
-        <p:nvSpPr>
-          <p:cNvPr id="24" name="Text 22"/>
-          <p:cNvSpPr/>
-          <p:nvPr/>
-        </p:nvSpPr>
-        <p:spPr>
-          <a:xfrm>
-            <a:off x="7223760" y="3035808"/>
-            <a:ext cx="4206240" cy="411480"/>
-          </a:xfrm>
-          <a:prstGeom prst="rect">
-            <a:avLst/>
-          </a:prstGeom>
-          <a:noFill/>
-          <a:ln/>
-        </p:spPr>
-        <p:txBody>
-          <a:bodyPr wrap="square" rtlCol="0" anchor="ctr"/>
-          <a:lstStyle/>
-          <a:p>
-            <a:pPr indent="0" marL="0">
-              <a:buNone/>
-            </a:pPr>
-            <a:r>
-              <a:rPr lang="en-US" sz="1500" b="1" dirty="0">
-                <a:solidFill>
-                  <a:srgbClr val="1A2233"/>
-                </a:solidFill>
-                <a:latin typeface="Trebuchet MS" pitchFamily="34" charset="0"/>
-                <a:ea typeface="Trebuchet MS" pitchFamily="34" charset="-122"/>
-                <a:cs typeface="Trebuchet MS" pitchFamily="34" charset="-120"/>
-              </a:rPr>
-              <a:t>Persistance des donnees</a:t>
-            </a:r>
-            <a:endParaRPr lang="en-US" sz="1500" dirty="0"/>
-          </a:p>
-        </p:txBody>
-      </p:sp>
-      <p:sp>
-        <p:nvSpPr>
-          <p:cNvPr id="25" name="Text 23"/>
-          <p:cNvSpPr/>
-          <p:nvPr/>
-        </p:nvSpPr>
-        <p:spPr>
-          <a:xfrm>
-            <a:off x="7223760" y="3438144"/>
-            <a:ext cx="4251960" cy="502920"/>
-          </a:xfrm>
-          <a:prstGeom prst="rect">
-            <a:avLst/>
-          </a:prstGeom>
-          <a:noFill/>
-          <a:ln/>
-        </p:spPr>
-        <p:txBody>
-          <a:bodyPr wrap="square" rtlCol="0" anchor="ctr"/>
-          <a:lstStyle/>
-          <a:p>
-            <a:pPr indent="0" marL="0">
-              <a:buNone/>
-            </a:pPr>
-            <a:r>
-              <a:rPr lang="en-US" sz="1050" dirty="0">
-                <a:solidFill>
-                  <a:srgbClr val="5B6B7F"/>
-                </a:solidFill>
-                <a:latin typeface="Consolas" pitchFamily="34" charset="0"/>
-                <a:ea typeface="Consolas" pitchFamily="34" charset="-122"/>
-                <a:cs typeface="Consolas" pitchFamily="34" charset="-120"/>
-              </a:rPr>
-              <a:t>commande conservee apres delete du Pod</a:t>
-            </a:r>
-            <a:endParaRPr lang="en-US" sz="1050" dirty="0"/>
-          </a:p>
-        </p:txBody>
-      </p:sp>
-      <p:sp>
-        <p:nvSpPr>
-          <p:cNvPr id="26" name="Shape 24"/>
-          <p:cNvSpPr/>
-          <p:nvPr/>
-        </p:nvSpPr>
-        <p:spPr>
-          <a:xfrm>
-            <a:off x="548640" y="4389120"/>
-            <a:ext cx="11064240" cy="1737360"/>
+                <a:latin typeface="Calibri" pitchFamily="34" charset="0"/>
+                <a:ea typeface="Calibri" pitchFamily="34" charset="-122"/>
+                <a:cs typeface="Calibri" pitchFamily="34" charset="-120"/>
+              </a:rPr>
+              <a:t>kubectl get all,pv,pvc - pods Running, PV/PVC Bound, /api/health OK</a:t>
+            </a:r>
+            <a:endParaRPr lang="en-US" sz="950" dirty="0"/>
+          </a:p>
+        </p:txBody>
+      </p:sp>
+      <p:sp>
+        <p:nvSpPr>
+          <p:cNvPr id="14" name="Shape 10"/>
+          <p:cNvSpPr/>
+          <p:nvPr/>
+        </p:nvSpPr>
+        <p:spPr>
+          <a:xfrm>
+            <a:off x="457200" y="5303520"/>
+            <a:ext cx="2706624" cy="914400"/>
           </a:xfrm>
           <a:prstGeom prst="rect">
             <a:avLst/>
@@ -3222,31 +2812,24 @@
           </a:solidFill>
           <a:ln w="12700">
             <a:solidFill>
-              <a:srgbClr val="DDE3EC"/>
+              <a:srgbClr val="86EFAC"/>
             </a:solidFill>
             <a:prstDash val="solid"/>
           </a:ln>
-          <a:effectLst>
-            <a:outerShdw sx="100000" sy="100000" kx="0" ky="0" algn="bl" rotWithShape="0" blurRad="101600" dist="38100" dir="8100000">
-              <a:srgbClr val="000000">
-                <a:alpha val="16000"/>
-              </a:srgbClr>
-            </a:outerShdw>
-          </a:effectLst>
-        </p:spPr>
-      </p:sp>
-      <p:sp>
-        <p:nvSpPr>
-          <p:cNvPr id="27" name="Shape 25"/>
-          <p:cNvSpPr/>
-          <p:nvPr/>
-        </p:nvSpPr>
-        <p:spPr>
-          <a:xfrm>
-            <a:off x="548640" y="4389120"/>
-            <a:ext cx="109728" cy="1737360"/>
-          </a:xfrm>
-          <a:prstGeom prst="rect">
+        </p:spPr>
+      </p:sp>
+      <p:sp>
+        <p:nvSpPr>
+          <p:cNvPr id="15" name="Shape 11"/>
+          <p:cNvSpPr/>
+          <p:nvPr/>
+        </p:nvSpPr>
+        <p:spPr>
+          <a:xfrm>
+            <a:off x="640080" y="5550408"/>
+            <a:ext cx="420624" cy="420624"/>
+          </a:xfrm>
+          <a:prstGeom prst="ellipse">
             <a:avLst/>
           </a:prstGeom>
           <a:solidFill>
@@ -3257,14 +2840,14 @@
       </p:sp>
       <p:sp>
         <p:nvSpPr>
-          <p:cNvPr id="28" name="Text 26"/>
-          <p:cNvSpPr/>
-          <p:nvPr/>
-        </p:nvSpPr>
-        <p:spPr>
-          <a:xfrm>
-            <a:off x="868680" y="4526280"/>
-            <a:ext cx="10515600" cy="365760"/>
+          <p:cNvPr id="16" name="Text 12"/>
+          <p:cNvSpPr/>
+          <p:nvPr/>
+        </p:nvSpPr>
+        <p:spPr>
+          <a:xfrm>
+            <a:off x="640080" y="5550408"/>
+            <a:ext cx="420624" cy="420624"/>
           </a:xfrm>
           <a:prstGeom prst="rect">
             <a:avLst/>
@@ -3276,34 +2859,34 @@
           <a:bodyPr wrap="square" rtlCol="0" anchor="ctr"/>
           <a:lstStyle/>
           <a:p>
-            <a:pPr indent="0" marL="0">
-              <a:buNone/>
-            </a:pPr>
-            <a:r>
-              <a:rPr lang="en-US" sz="1600" b="1" dirty="0">
-                <a:solidFill>
-                  <a:srgbClr val="16A34A"/>
+            <a:pPr algn="ctr" indent="0" marL="0">
+              <a:buNone/>
+            </a:pPr>
+            <a:r>
+              <a:rPr lang="en-US" sz="1500" b="1" dirty="0">
+                <a:solidFill>
+                  <a:srgbClr val="FFFFFF"/>
                 </a:solidFill>
                 <a:latin typeface="Trebuchet MS" pitchFamily="34" charset="0"/>
                 <a:ea typeface="Trebuchet MS" pitchFamily="34" charset="-122"/>
                 <a:cs typeface="Trebuchet MS" pitchFamily="34" charset="-120"/>
               </a:rPr>
-              <a:t>Resultat</a:t>
-            </a:r>
-            <a:endParaRPr lang="en-US" sz="1600" dirty="0"/>
-          </a:p>
-        </p:txBody>
-      </p:sp>
-      <p:sp>
-        <p:nvSpPr>
-          <p:cNvPr id="29" name="Text 27"/>
-          <p:cNvSpPr/>
-          <p:nvPr/>
-        </p:nvSpPr>
-        <p:spPr>
-          <a:xfrm>
-            <a:off x="868680" y="4937760"/>
-            <a:ext cx="10515600" cy="1097280"/>
+              <a:t>A</a:t>
+            </a:r>
+            <a:endParaRPr lang="en-US" sz="1500" dirty="0"/>
+          </a:p>
+        </p:txBody>
+      </p:sp>
+      <p:sp>
+        <p:nvSpPr>
+          <p:cNvPr id="17" name="Text 13"/>
+          <p:cNvSpPr/>
+          <p:nvPr/>
+        </p:nvSpPr>
+        <p:spPr>
+          <a:xfrm>
+            <a:off x="1170432" y="5440680"/>
+            <a:ext cx="1874520" cy="640080"/>
           </a:xfrm>
           <a:prstGeom prst="rect">
             <a:avLst/>
@@ -3315,82 +2898,426 @@
           <a:bodyPr wrap="square" rtlCol="0" anchor="ctr"/>
           <a:lstStyle/>
           <a:p>
-            <a:pPr marL="342900" indent="-342900">
-              <a:spcAft>
-                <a:spcPts val="600"/>
-              </a:spcAft>
-              <a:buSzPct val="100000"/>
-              <a:buChar char="•"/>
-            </a:pPr>
-            <a:r>
-              <a:rPr lang="en-US" sz="1300" dirty="0">
+            <a:pPr indent="0" marL="0">
+              <a:buNone/>
+            </a:pPr>
+            <a:r>
+              <a:rPr lang="en-US" sz="1200" b="1" dirty="0">
                 <a:solidFill>
                   <a:srgbClr val="1A2233"/>
+                </a:solidFill>
+                <a:latin typeface="Trebuchet MS" pitchFamily="34" charset="0"/>
+                <a:ea typeface="Trebuchet MS" pitchFamily="34" charset="-122"/>
+                <a:cs typeface="Trebuchet MS" pitchFamily="34" charset="-120"/>
+              </a:rPr>
+              <a:t>Frontend accessible</a:t>
+            </a:r>
+            <a:endParaRPr lang="en-US" sz="1200" dirty="0"/>
+          </a:p>
+        </p:txBody>
+      </p:sp>
+      <p:sp>
+        <p:nvSpPr>
+          <p:cNvPr id="18" name="Shape 14"/>
+          <p:cNvSpPr/>
+          <p:nvPr/>
+        </p:nvSpPr>
+        <p:spPr>
+          <a:xfrm>
+            <a:off x="3282696" y="5303520"/>
+            <a:ext cx="2706624" cy="914400"/>
+          </a:xfrm>
+          <a:prstGeom prst="rect">
+            <a:avLst/>
+          </a:prstGeom>
+          <a:solidFill>
+            <a:srgbClr val="ECFDF5"/>
+          </a:solidFill>
+          <a:ln w="12700">
+            <a:solidFill>
+              <a:srgbClr val="86EFAC"/>
+            </a:solidFill>
+            <a:prstDash val="solid"/>
+          </a:ln>
+        </p:spPr>
+      </p:sp>
+      <p:sp>
+        <p:nvSpPr>
+          <p:cNvPr id="19" name="Shape 15"/>
+          <p:cNvSpPr/>
+          <p:nvPr/>
+        </p:nvSpPr>
+        <p:spPr>
+          <a:xfrm>
+            <a:off x="3465576" y="5550408"/>
+            <a:ext cx="420624" cy="420624"/>
+          </a:xfrm>
+          <a:prstGeom prst="ellipse">
+            <a:avLst/>
+          </a:prstGeom>
+          <a:solidFill>
+            <a:srgbClr val="16A34A"/>
+          </a:solidFill>
+          <a:ln/>
+        </p:spPr>
+      </p:sp>
+      <p:sp>
+        <p:nvSpPr>
+          <p:cNvPr id="20" name="Text 16"/>
+          <p:cNvSpPr/>
+          <p:nvPr/>
+        </p:nvSpPr>
+        <p:spPr>
+          <a:xfrm>
+            <a:off x="3465576" y="5550408"/>
+            <a:ext cx="420624" cy="420624"/>
+          </a:xfrm>
+          <a:prstGeom prst="rect">
+            <a:avLst/>
+          </a:prstGeom>
+          <a:noFill/>
+          <a:ln/>
+        </p:spPr>
+        <p:txBody>
+          <a:bodyPr wrap="square" rtlCol="0" anchor="ctr"/>
+          <a:lstStyle/>
+          <a:p>
+            <a:pPr algn="ctr" indent="0" marL="0">
+              <a:buNone/>
+            </a:pPr>
+            <a:r>
+              <a:rPr lang="en-US" sz="1500" b="1" dirty="0">
+                <a:solidFill>
+                  <a:srgbClr val="FFFFFF"/>
+                </a:solidFill>
+                <a:latin typeface="Trebuchet MS" pitchFamily="34" charset="0"/>
+                <a:ea typeface="Trebuchet MS" pitchFamily="34" charset="-122"/>
+                <a:cs typeface="Trebuchet MS" pitchFamily="34" charset="-120"/>
+              </a:rPr>
+              <a:t>B</a:t>
+            </a:r>
+            <a:endParaRPr lang="en-US" sz="1500" dirty="0"/>
+          </a:p>
+        </p:txBody>
+      </p:sp>
+      <p:sp>
+        <p:nvSpPr>
+          <p:cNvPr id="21" name="Text 17"/>
+          <p:cNvSpPr/>
+          <p:nvPr/>
+        </p:nvSpPr>
+        <p:spPr>
+          <a:xfrm>
+            <a:off x="3995928" y="5440680"/>
+            <a:ext cx="1874520" cy="640080"/>
+          </a:xfrm>
+          <a:prstGeom prst="rect">
+            <a:avLst/>
+          </a:prstGeom>
+          <a:noFill/>
+          <a:ln/>
+        </p:spPr>
+        <p:txBody>
+          <a:bodyPr wrap="square" rtlCol="0" anchor="ctr"/>
+          <a:lstStyle/>
+          <a:p>
+            <a:pPr indent="0" marL="0">
+              <a:buNone/>
+            </a:pPr>
+            <a:r>
+              <a:rPr lang="en-US" sz="1200" b="1" dirty="0">
+                <a:solidFill>
+                  <a:srgbClr val="1A2233"/>
+                </a:solidFill>
+                <a:latin typeface="Trebuchet MS" pitchFamily="34" charset="0"/>
+                <a:ea typeface="Trebuchet MS" pitchFamily="34" charset="-122"/>
+                <a:cs typeface="Trebuchet MS" pitchFamily="34" charset="-120"/>
+              </a:rPr>
+              <a:t>Front &lt;-&gt; Back</a:t>
+            </a:r>
+            <a:endParaRPr lang="en-US" sz="1200" dirty="0"/>
+          </a:p>
+        </p:txBody>
+      </p:sp>
+      <p:sp>
+        <p:nvSpPr>
+          <p:cNvPr id="22" name="Shape 18"/>
+          <p:cNvSpPr/>
+          <p:nvPr/>
+        </p:nvSpPr>
+        <p:spPr>
+          <a:xfrm>
+            <a:off x="6108192" y="5303520"/>
+            <a:ext cx="2706624" cy="914400"/>
+          </a:xfrm>
+          <a:prstGeom prst="rect">
+            <a:avLst/>
+          </a:prstGeom>
+          <a:solidFill>
+            <a:srgbClr val="ECFDF5"/>
+          </a:solidFill>
+          <a:ln w="12700">
+            <a:solidFill>
+              <a:srgbClr val="86EFAC"/>
+            </a:solidFill>
+            <a:prstDash val="solid"/>
+          </a:ln>
+        </p:spPr>
+      </p:sp>
+      <p:sp>
+        <p:nvSpPr>
+          <p:cNvPr id="23" name="Shape 19"/>
+          <p:cNvSpPr/>
+          <p:nvPr/>
+        </p:nvSpPr>
+        <p:spPr>
+          <a:xfrm>
+            <a:off x="6291072" y="5550408"/>
+            <a:ext cx="420624" cy="420624"/>
+          </a:xfrm>
+          <a:prstGeom prst="ellipse">
+            <a:avLst/>
+          </a:prstGeom>
+          <a:solidFill>
+            <a:srgbClr val="16A34A"/>
+          </a:solidFill>
+          <a:ln/>
+        </p:spPr>
+      </p:sp>
+      <p:sp>
+        <p:nvSpPr>
+          <p:cNvPr id="24" name="Text 20"/>
+          <p:cNvSpPr/>
+          <p:nvPr/>
+        </p:nvSpPr>
+        <p:spPr>
+          <a:xfrm>
+            <a:off x="6291072" y="5550408"/>
+            <a:ext cx="420624" cy="420624"/>
+          </a:xfrm>
+          <a:prstGeom prst="rect">
+            <a:avLst/>
+          </a:prstGeom>
+          <a:noFill/>
+          <a:ln/>
+        </p:spPr>
+        <p:txBody>
+          <a:bodyPr wrap="square" rtlCol="0" anchor="ctr"/>
+          <a:lstStyle/>
+          <a:p>
+            <a:pPr algn="ctr" indent="0" marL="0">
+              <a:buNone/>
+            </a:pPr>
+            <a:r>
+              <a:rPr lang="en-US" sz="1500" b="1" dirty="0">
+                <a:solidFill>
+                  <a:srgbClr val="FFFFFF"/>
+                </a:solidFill>
+                <a:latin typeface="Trebuchet MS" pitchFamily="34" charset="0"/>
+                <a:ea typeface="Trebuchet MS" pitchFamily="34" charset="-122"/>
+                <a:cs typeface="Trebuchet MS" pitchFamily="34" charset="-120"/>
+              </a:rPr>
+              <a:t>C</a:t>
+            </a:r>
+            <a:endParaRPr lang="en-US" sz="1500" dirty="0"/>
+          </a:p>
+        </p:txBody>
+      </p:sp>
+      <p:sp>
+        <p:nvSpPr>
+          <p:cNvPr id="25" name="Text 21"/>
+          <p:cNvSpPr/>
+          <p:nvPr/>
+        </p:nvSpPr>
+        <p:spPr>
+          <a:xfrm>
+            <a:off x="6821424" y="5440680"/>
+            <a:ext cx="1874520" cy="640080"/>
+          </a:xfrm>
+          <a:prstGeom prst="rect">
+            <a:avLst/>
+          </a:prstGeom>
+          <a:noFill/>
+          <a:ln/>
+        </p:spPr>
+        <p:txBody>
+          <a:bodyPr wrap="square" rtlCol="0" anchor="ctr"/>
+          <a:lstStyle/>
+          <a:p>
+            <a:pPr indent="0" marL="0">
+              <a:buNone/>
+            </a:pPr>
+            <a:r>
+              <a:rPr lang="en-US" sz="1200" b="1" dirty="0">
+                <a:solidFill>
+                  <a:srgbClr val="1A2233"/>
+                </a:solidFill>
+                <a:latin typeface="Trebuchet MS" pitchFamily="34" charset="0"/>
+                <a:ea typeface="Trebuchet MS" pitchFamily="34" charset="-122"/>
+                <a:cs typeface="Trebuchet MS" pitchFamily="34" charset="-120"/>
+              </a:rPr>
+              <a:t>Back &lt;-&gt; MongoDB</a:t>
+            </a:r>
+            <a:endParaRPr lang="en-US" sz="1200" dirty="0"/>
+          </a:p>
+        </p:txBody>
+      </p:sp>
+      <p:sp>
+        <p:nvSpPr>
+          <p:cNvPr id="26" name="Shape 22"/>
+          <p:cNvSpPr/>
+          <p:nvPr/>
+        </p:nvSpPr>
+        <p:spPr>
+          <a:xfrm>
+            <a:off x="8933688" y="5303520"/>
+            <a:ext cx="2706624" cy="914400"/>
+          </a:xfrm>
+          <a:prstGeom prst="rect">
+            <a:avLst/>
+          </a:prstGeom>
+          <a:solidFill>
+            <a:srgbClr val="ECFDF5"/>
+          </a:solidFill>
+          <a:ln w="12700">
+            <a:solidFill>
+              <a:srgbClr val="86EFAC"/>
+            </a:solidFill>
+            <a:prstDash val="solid"/>
+          </a:ln>
+        </p:spPr>
+      </p:sp>
+      <p:sp>
+        <p:nvSpPr>
+          <p:cNvPr id="27" name="Shape 23"/>
+          <p:cNvSpPr/>
+          <p:nvPr/>
+        </p:nvSpPr>
+        <p:spPr>
+          <a:xfrm>
+            <a:off x="9116568" y="5550408"/>
+            <a:ext cx="420624" cy="420624"/>
+          </a:xfrm>
+          <a:prstGeom prst="ellipse">
+            <a:avLst/>
+          </a:prstGeom>
+          <a:solidFill>
+            <a:srgbClr val="16A34A"/>
+          </a:solidFill>
+          <a:ln/>
+        </p:spPr>
+      </p:sp>
+      <p:sp>
+        <p:nvSpPr>
+          <p:cNvPr id="28" name="Text 24"/>
+          <p:cNvSpPr/>
+          <p:nvPr/>
+        </p:nvSpPr>
+        <p:spPr>
+          <a:xfrm>
+            <a:off x="9116568" y="5550408"/>
+            <a:ext cx="420624" cy="420624"/>
+          </a:xfrm>
+          <a:prstGeom prst="rect">
+            <a:avLst/>
+          </a:prstGeom>
+          <a:noFill/>
+          <a:ln/>
+        </p:spPr>
+        <p:txBody>
+          <a:bodyPr wrap="square" rtlCol="0" anchor="ctr"/>
+          <a:lstStyle/>
+          <a:p>
+            <a:pPr algn="ctr" indent="0" marL="0">
+              <a:buNone/>
+            </a:pPr>
+            <a:r>
+              <a:rPr lang="en-US" sz="1500" b="1" dirty="0">
+                <a:solidFill>
+                  <a:srgbClr val="FFFFFF"/>
+                </a:solidFill>
+                <a:latin typeface="Trebuchet MS" pitchFamily="34" charset="0"/>
+                <a:ea typeface="Trebuchet MS" pitchFamily="34" charset="-122"/>
+                <a:cs typeface="Trebuchet MS" pitchFamily="34" charset="-120"/>
+              </a:rPr>
+              <a:t>D</a:t>
+            </a:r>
+            <a:endParaRPr lang="en-US" sz="1500" dirty="0"/>
+          </a:p>
+        </p:txBody>
+      </p:sp>
+      <p:sp>
+        <p:nvSpPr>
+          <p:cNvPr id="29" name="Text 25"/>
+          <p:cNvSpPr/>
+          <p:nvPr/>
+        </p:nvSpPr>
+        <p:spPr>
+          <a:xfrm>
+            <a:off x="9646920" y="5440680"/>
+            <a:ext cx="1874520" cy="640080"/>
+          </a:xfrm>
+          <a:prstGeom prst="rect">
+            <a:avLst/>
+          </a:prstGeom>
+          <a:noFill/>
+          <a:ln/>
+        </p:spPr>
+        <p:txBody>
+          <a:bodyPr wrap="square" rtlCol="0" anchor="ctr"/>
+          <a:lstStyle/>
+          <a:p>
+            <a:pPr indent="0" marL="0">
+              <a:buNone/>
+            </a:pPr>
+            <a:r>
+              <a:rPr lang="en-US" sz="1200" b="1" dirty="0">
+                <a:solidFill>
+                  <a:srgbClr val="1A2233"/>
+                </a:solidFill>
+                <a:latin typeface="Trebuchet MS" pitchFamily="34" charset="0"/>
+                <a:ea typeface="Trebuchet MS" pitchFamily="34" charset="-122"/>
+                <a:cs typeface="Trebuchet MS" pitchFamily="34" charset="-120"/>
+              </a:rPr>
+              <a:t>Persistance OK</a:t>
+            </a:r>
+            <a:endParaRPr lang="en-US" sz="1200" dirty="0"/>
+          </a:p>
+        </p:txBody>
+      </p:sp>
+      <p:sp>
+        <p:nvSpPr>
+          <p:cNvPr id="30" name="Text 26"/>
+          <p:cNvSpPr/>
+          <p:nvPr/>
+        </p:nvSpPr>
+        <p:spPr>
+          <a:xfrm>
+            <a:off x="548640" y="6455664"/>
+            <a:ext cx="6400800" cy="274320"/>
+          </a:xfrm>
+          <a:prstGeom prst="rect">
+            <a:avLst/>
+          </a:prstGeom>
+          <a:noFill/>
+          <a:ln/>
+        </p:spPr>
+        <p:txBody>
+          <a:bodyPr wrap="square" rtlCol="0" anchor="ctr"/>
+          <a:lstStyle/>
+          <a:p>
+            <a:pPr indent="0" marL="0">
+              <a:buNone/>
+            </a:pPr>
+            <a:r>
+              <a:rPr lang="en-US" sz="900" dirty="0">
+                <a:solidFill>
+                  <a:srgbClr val="5B6B7F"/>
                 </a:solidFill>
                 <a:latin typeface="Calibri" pitchFamily="34" charset="0"/>
                 <a:ea typeface="Calibri" pitchFamily="34" charset="-122"/>
                 <a:cs typeface="Calibri" pitchFamily="34" charset="-120"/>
               </a:rPr>
-              <a:t>Les 4 verifications imposees passent : accessibilite, communication front&lt;-&gt;back, back&lt;-&gt;base, et persistance.</a:t>
-            </a:r>
-            <a:endParaRPr lang="en-US" sz="1300" dirty="0"/>
-          </a:p>
-          <a:p>
-            <a:pPr marL="342900" indent="-342900">
-              <a:spcAft>
-                <a:spcPts val="600"/>
-              </a:spcAft>
-              <a:buSzPct val="100000"/>
-              <a:buChar char="•"/>
-            </a:pPr>
-            <a:r>
-              <a:rPr lang="en-US" sz="1300" dirty="0">
-                <a:solidFill>
-                  <a:srgbClr val="D97706"/>
-                </a:solidFill>
-                <a:latin typeface="Calibri" pitchFamily="34" charset="0"/>
-                <a:ea typeface="Calibri" pitchFamily="34" charset="-122"/>
-                <a:cs typeface="Calibri" pitchFamily="34" charset="-120"/>
-              </a:rPr>
-              <a:t>Capture(s) d'ecran a inserer ici (kubectl get all, page e-commerce, page Prometheus Targets UP).</a:t>
-            </a:r>
-            <a:endParaRPr lang="en-US" sz="1300" dirty="0"/>
-          </a:p>
-        </p:txBody>
-      </p:sp>
-      <p:sp>
-        <p:nvSpPr>
-          <p:cNvPr id="30" name="Text 28"/>
-          <p:cNvSpPr/>
-          <p:nvPr/>
-        </p:nvSpPr>
-        <p:spPr>
-          <a:xfrm>
-            <a:off x="548640" y="6455664"/>
-            <a:ext cx="6400800" cy="274320"/>
-          </a:xfrm>
-          <a:prstGeom prst="rect">
-            <a:avLst/>
-          </a:prstGeom>
-          <a:noFill/>
-          <a:ln/>
-        </p:spPr>
-        <p:txBody>
-          <a:bodyPr wrap="square" rtlCol="0" anchor="ctr"/>
-          <a:lstStyle/>
-          <a:p>
-            <a:pPr indent="0" marL="0">
-              <a:buNone/>
-            </a:pPr>
-            <a:r>
-              <a:rPr lang="en-US" sz="900" dirty="0">
-                <a:solidFill>
-                  <a:srgbClr val="5B6B7F"/>
-                </a:solidFill>
-                <a:latin typeface="Calibri" pitchFamily="34" charset="0"/>
-                <a:ea typeface="Calibri" pitchFamily="34" charset="-122"/>
-                <a:cs typeface="Calibri" pitchFamily="34" charset="-120"/>
-              </a:rPr>
               <a:t>K8s E-Commerce  |  Projet DevOps</a:t>
             </a:r>
             <a:endParaRPr lang="en-US" sz="900" dirty="0"/>
@@ -3399,7 +3326,7 @@
       </p:sp>
       <p:sp>
         <p:nvSpPr>
-          <p:cNvPr id="31" name="Text 29"/>
+          <p:cNvPr id="31" name="Text 27"/>
           <p:cNvSpPr/>
           <p:nvPr/>
         </p:nvSpPr>
@@ -6009,8 +5936,8 @@
         </p:nvSpPr>
         <p:spPr>
           <a:xfrm>
-            <a:off x="7772400" y="5852160"/>
-            <a:ext cx="3840480" cy="457200"/>
+            <a:off x="7315200" y="5852160"/>
+            <a:ext cx="4297680" cy="457200"/>
           </a:xfrm>
           <a:prstGeom prst="rect">
             <a:avLst/>
@@ -6034,7 +5961,7 @@
                 <a:ea typeface="Consolas" pitchFamily="34" charset="-122"/>
                 <a:cs typeface="Consolas" pitchFamily="34" charset="-120"/>
               </a:rPr>
-              <a:t>github.com/&lt;equipe&gt;/k8s-ecommerce</a:t>
+              <a:t>github.com/Abder541/k8s-ecommerce</a:t>
             </a:r>
             <a:endParaRPr lang="en-US" sz="1200" dirty="0"/>
           </a:p>

</xml_diff>

<commit_message>
PowerPoint : notes du presentateur (langage simple) sur les 13 slides
Co-Authored-By: Claude Opus 4.8 <noreply@anthropic.com>
</commit_message>
<xml_diff>
--- a/presentation/K8s-ECommerce-Presentation.pptx
+++ b/presentation/K8s-ECommerce-Presentation.pptx
@@ -514,7 +514,9 @@
           <a:p>
             <a:r>
               <a:rPr lang="en-US" dirty="0"/>
-              <a:t/>
+              <a:t>Bonjour. Je vais vous presenter mon projet : mettre en ligne une boutique e-commerce sur Kubernetes.
+L'application a trois parties : l'interface du site que voit le client, le moteur qui gere la logique (les produits, les commandes), et la base de donnees qui garde les informations.
+Tout est automatise : le systeme lance les parties, les surveille, et les repare tout seul si l'une tombe en panne.</a:t>
             </a:r>
             <a:endParaRPr lang="en-US" dirty="0"/>
           </a:p>
@@ -602,7 +604,10 @@
           <a:p>
             <a:r>
               <a:rPr lang="en-US" dirty="0"/>
-              <a:t/>
+              <a:t>Voici la preuve que tout fonctionne, avec deux captures reelles.
+A gauche : le site en ligne avec son catalogue de produits. Les produits viennent bien de la base de donnees, en passant par le moteur.
+A droite : l'etat du systeme. Toutes les parties sont actives, l'espace de stockage est bien relie, et le moteur repond correctement.
+En bas, les quatre verifications demandees dans le sujet : le site est accessible, le site parle au moteur, le moteur parle a la base, et les donnees resistent au redemarrage. Les quatre sont validees.</a:t>
             </a:r>
             <a:endParaRPr lang="en-US" dirty="0"/>
           </a:p>
@@ -690,7 +695,10 @@
           <a:p>
             <a:r>
               <a:rPr lang="en-US" dirty="0"/>
-              <a:t/>
+              <a:t>J'ai voulu aller au-dela du minimum demande, avec trois choses en plus.
+Un : la securisation des mots de passe, ranges de facon protegee.
+Deux : j'ai prepare une version capable de tourner sur plusieurs machines, pas seulement une.
+Trois : j'ai ajoute un systeme de surveillance (Prometheus et Grafana) qui permet de suivre l'activite de l'application avec des graphiques. Les fichiers de configuration sont fournis et le moteur est prepare pour ca.</a:t>
             </a:r>
             <a:endParaRPr lang="en-US" dirty="0"/>
           </a:p>
@@ -778,7 +786,9 @@
           <a:p>
             <a:r>
               <a:rPr lang="en-US" dirty="0"/>
-              <a:t/>
+              <a:t>J'ai rencontre plusieurs obstacles, et pour chacun j'ai trouve une solution. Le tableau les resume.
+L'exemple le plus parlant : au demarrage, le moteur essayait de se connecter a la base de donnees avant qu'elle soit prete, donc ca plantait. Je l'ai regle en faisant reessayer le moteur plusieurs fois jusqu'a ce que la base reponde.
+L'idee a retenir : c'est normal d'avoir des problemes, l'important c'est de comprendre la cause et de la corriger. C'est ce qui m'a le plus appris.</a:t>
             </a:r>
             <a:endParaRPr lang="en-US" dirty="0"/>
           </a:p>
@@ -866,7 +876,10 @@
           <a:p>
             <a:r>
               <a:rPr lang="en-US" dirty="0"/>
-              <a:t/>
+              <a:t>Pour conclure.
+A gauche, ce que j'ai livre : une application e-commerce complete, qui respecte l'architecture demandee, avec des donnees qui ne se perdent pas.
+A droite, les ameliorations possibles si on continuait : ajouter une connexion securisee HTTPS, un systeme qui ajoute automatiquement des ressources quand il y a beaucoup de visiteurs, et une mise a jour automatisee.
+Je termine par : merci de votre attention, je suis disponible pour repondre a vos questions.</a:t>
             </a:r>
             <a:endParaRPr lang="en-US" dirty="0"/>
           </a:p>
@@ -954,7 +967,9 @@
           <a:p>
             <a:r>
               <a:rPr lang="en-US" dirty="0"/>
-              <a:t/>
+              <a:t>Le but du projet : prendre une application complete et la faire tourner dans un environnement capable de la gerer automatiquement.
+Une contrainte etait imposee, c'est le tableau a droite : l'interface du site doit etre seule d'un cote (Pod 1), et le moteur avec la base de donnees ensemble de l'autre (Pod 2). J'ai respecte cette organisation.
+En bas, ce sont les criteres de notation : le plus important, c'est que l'application fonctionne vraiment.</a:t>
             </a:r>
             <a:endParaRPr lang="en-US" dirty="0"/>
           </a:p>
@@ -1042,7 +1057,10 @@
           <a:p>
             <a:r>
               <a:rPr lang="en-US" dirty="0"/>
-              <a:t/>
+              <a:t>Voici comment tout est relie. Je suis le chemin d'une visite :
+Le client arrive sur le site par une adresse (en haut a gauche). Le site ne calcule rien lui-meme : il transmet les demandes au moteur, qui est juste en dessous.
+Le moteur va chercher ou enregistrer les informations dans la base de donnees, qui est juste a cote de lui (ils sont dans le meme groupe, le Pod 2).
+Et point important : les donnees de la base sont ecrites sur un espace de stockage qui ne s'efface pas, meme si une partie redemarre. C'est la fleche vers le bas, le volume.</a:t>
             </a:r>
             <a:endParaRPr lang="en-US" dirty="0"/>
           </a:p>
@@ -1130,7 +1148,10 @@
           <a:p>
             <a:r>
               <a:rPr lang="en-US" dirty="0"/>
-              <a:t/>
+              <a:t>Voici les technologies que j'ai choisies.
+Pour l'interface du site : React. Pour le moteur : Node.js. Pour la base de donnees : MongoDB. Ce sont trois technologies qui se marient bien et que je connais.
+Pour faire tourner Kubernetes sur mon ordinateur, j'ai utilise un outil leger appele kind, qui cree un vrai environnement Kubernetes facile a relancer a l'identique.
+L'idee generale : une organisation simple, rapide a tester, et qui se reproduit en une commande.</a:t>
             </a:r>
             <a:endParaRPr lang="en-US" dirty="0"/>
           </a:p>
@@ -1218,7 +1239,9 @@
           <a:p>
             <a:r>
               <a:rPr lang="en-US" dirty="0"/>
-              <a:t/>
+              <a:t>Chaque partie de l'application est emballee dans un paquet autonome qui contient tout ce qu'il faut pour fonctionner. Ca garantit que ca marche pareil partout.
+A gauche, la recette pour le moteur. A droite, celle du site : je l'ai faite en deux temps. D'abord je fabrique le site, puis je ne garde que le resultat final dans un paquet tres leger.
+Resultat, en bas : le paquet du site ne pese que 21 megaoctets au lieu de plusieurs centaines. C'est plus rapide a demarrer.</a:t>
             </a:r>
             <a:endParaRPr lang="en-US" dirty="0"/>
           </a:p>
@@ -1306,7 +1329,10 @@
           <a:p>
             <a:r>
               <a:rPr lang="en-US" dirty="0"/>
-              <a:t/>
+              <a:t>Ici je montre comment je cree l'environnement Kubernetes.
+Une seule commande suffit pour le creer (en haut a gauche). A droite, on voit que la machine est bien active et prete.
+Comme mes paquets sont fabriques sur mon ordinateur, je les injecte directement dans l'environnement, sans avoir besoin de les publier sur internet. Tout reste en local, c'est rapide.
+Si on me demande : kind, c'est un vrai Kubernetes, juste installe de facon legere sur un PC.</a:t>
             </a:r>
             <a:endParaRPr lang="en-US" dirty="0"/>
           </a:p>
@@ -1394,7 +1420,10 @@
           <a:p>
             <a:r>
               <a:rPr lang="en-US" dirty="0"/>
-              <a:t/>
+              <a:t>Le tableau montre mes trois groupes d'application et comment ils sont geres.
+Chaque partie est surveillee en permanence : si elle plante, le systeme la relance tout seul, sans intervention. C'est la colonne 'Sondes'.
+J'ai aussi mis des limites pour qu'aucune partie ne consomme trop de memoire.
+En bas a droite, j'explique un choix : pour la base de donnees, je l'arrete completement avant de la relancer lors d'une mise a jour. C'est pour eviter que deux versions touchent au meme espace de stockage en meme temps.</a:t>
             </a:r>
             <a:endParaRPr lang="en-US" dirty="0"/>
           </a:p>
@@ -1482,7 +1511,10 @@
           <a:p>
             <a:r>
               <a:rPr lang="en-US" dirty="0"/>
-              <a:t/>
+              <a:t>Ici, comment les parties se parlent et comment on accede a l'application.
+Le tableau montre les adresses : le site a une porte d'entree ouverte vers l'exterieur (le port 30080), donc accessible depuis un navigateur. Le moteur, lui, n'est joignable que de l'interieur, pour la securite.
+En bas, la chaine complete : du navigateur jusqu'a la base de donnees.
+Detail important : le site sert d'intermediaire et transmet les demandes au moteur. Comme ca, le navigateur ne parle qu'a une seule adresse, ce qui evite les blocages de securite des navigateurs.</a:t>
             </a:r>
             <a:endParaRPr lang="en-US" dirty="0"/>
           </a:p>
@@ -1570,7 +1602,10 @@
           <a:p>
             <a:r>
               <a:rPr lang="en-US" dirty="0"/>
-              <a:t/>
+              <a:t>C'est une slide cle. Deux sujets : garder les donnees, et proteger les mots de passe.
+A gauche : la base de donnees ecrit ses informations sur un espace de stockage reserve qui survit, meme si la base redemarre.
+En bas, le test que j'ai fait pour le prouver : je cree une commande, je supprime volontairement la partie base de donnees, le systeme la recree tout seul, et la commande est TOUJOURS la. C'est la preuve que rien n'est perdu.
+A droite : les mots de passe ne sont jamais ecrits en clair dans les fichiers, ils sont ranges a part de facon protegee.</a:t>
             </a:r>
             <a:endParaRPr lang="en-US" dirty="0"/>
           </a:p>
@@ -2529,7 +2564,7 @@
       </p:sp>
       <p:sp>
         <p:nvSpPr>
-          <p:cNvPr id="6" name="Shape 4"/>
+          <p:cNvPr id="7" name="Shape 4"/>
           <p:cNvSpPr/>
           <p:nvPr/>
         </p:nvSpPr>
@@ -2561,7 +2596,7 @@
       </p:sp>
       <p:sp>
         <p:nvSpPr>
-          <p:cNvPr id="7" name="Text 5"/>
+          <p:cNvPr id="8" name="Text 5"/>
           <p:cNvSpPr/>
           <p:nvPr/>
         </p:nvSpPr>
@@ -2600,7 +2635,7 @@
       </p:sp>
       <p:pic>
         <p:nvPicPr>
-          <p:cNvPr id="8" name="Image 0" descr="docs/screenshots/01-app-frontend.png">    </p:cNvPr>
+          <p:cNvPr id="9" name="Image 0" descr="docs/screenshots/01-app-frontend.png">    </p:cNvPr>
           <p:cNvPicPr>
             <a:picLocks noChangeAspect="1"/>
           </p:cNvPicPr>
@@ -2623,7 +2658,7 @@
       </p:pic>
       <p:sp>
         <p:nvSpPr>
-          <p:cNvPr id="9" name="Text 6"/>
+          <p:cNvPr id="10" name="Text 6"/>
           <p:cNvSpPr/>
           <p:nvPr/>
         </p:nvSpPr>
@@ -2662,7 +2697,7 @@
       </p:sp>
       <p:sp>
         <p:nvSpPr>
-          <p:cNvPr id="10" name="Shape 7"/>
+          <p:cNvPr id="11" name="Shape 7"/>
           <p:cNvSpPr/>
           <p:nvPr/>
         </p:nvSpPr>
@@ -2694,7 +2729,7 @@
       </p:sp>
       <p:sp>
         <p:nvSpPr>
-          <p:cNvPr id="11" name="Text 8"/>
+          <p:cNvPr id="12" name="Text 8"/>
           <p:cNvSpPr/>
           <p:nvPr/>
         </p:nvSpPr>
@@ -2733,7 +2768,7 @@
       </p:sp>
       <p:pic>
         <p:nvPicPr>
-          <p:cNvPr id="12" name="Image 1" descr="docs/screenshots/02-kubernetes-proof.png">    </p:cNvPr>
+          <p:cNvPr id="13" name="Image 1" descr="docs/screenshots/02-kubernetes-proof.png">    </p:cNvPr>
           <p:cNvPicPr>
             <a:picLocks noChangeAspect="1"/>
           </p:cNvPicPr>
@@ -2756,7 +2791,7 @@
       </p:pic>
       <p:sp>
         <p:nvSpPr>
-          <p:cNvPr id="13" name="Text 9"/>
+          <p:cNvPr id="14" name="Text 9"/>
           <p:cNvSpPr/>
           <p:nvPr/>
         </p:nvSpPr>
@@ -2795,7 +2830,7 @@
       </p:sp>
       <p:sp>
         <p:nvSpPr>
-          <p:cNvPr id="14" name="Shape 10"/>
+          <p:cNvPr id="15" name="Shape 10"/>
           <p:cNvSpPr/>
           <p:nvPr/>
         </p:nvSpPr>
@@ -2820,7 +2855,7 @@
       </p:sp>
       <p:sp>
         <p:nvSpPr>
-          <p:cNvPr id="15" name="Shape 11"/>
+          <p:cNvPr id="16" name="Shape 11"/>
           <p:cNvSpPr/>
           <p:nvPr/>
         </p:nvSpPr>
@@ -2840,7 +2875,7 @@
       </p:sp>
       <p:sp>
         <p:nvSpPr>
-          <p:cNvPr id="16" name="Text 12"/>
+          <p:cNvPr id="17" name="Text 12"/>
           <p:cNvSpPr/>
           <p:nvPr/>
         </p:nvSpPr>
@@ -2879,7 +2914,7 @@
       </p:sp>
       <p:sp>
         <p:nvSpPr>
-          <p:cNvPr id="17" name="Text 13"/>
+          <p:cNvPr id="18" name="Text 13"/>
           <p:cNvSpPr/>
           <p:nvPr/>
         </p:nvSpPr>
@@ -2918,7 +2953,7 @@
       </p:sp>
       <p:sp>
         <p:nvSpPr>
-          <p:cNvPr id="18" name="Shape 14"/>
+          <p:cNvPr id="19" name="Shape 14"/>
           <p:cNvSpPr/>
           <p:nvPr/>
         </p:nvSpPr>
@@ -2943,7 +2978,7 @@
       </p:sp>
       <p:sp>
         <p:nvSpPr>
-          <p:cNvPr id="19" name="Shape 15"/>
+          <p:cNvPr id="20" name="Shape 15"/>
           <p:cNvSpPr/>
           <p:nvPr/>
         </p:nvSpPr>
@@ -2963,7 +2998,7 @@
       </p:sp>
       <p:sp>
         <p:nvSpPr>
-          <p:cNvPr id="20" name="Text 16"/>
+          <p:cNvPr id="21" name="Text 16"/>
           <p:cNvSpPr/>
           <p:nvPr/>
         </p:nvSpPr>
@@ -3002,7 +3037,7 @@
       </p:sp>
       <p:sp>
         <p:nvSpPr>
-          <p:cNvPr id="21" name="Text 17"/>
+          <p:cNvPr id="22" name="Text 17"/>
           <p:cNvSpPr/>
           <p:nvPr/>
         </p:nvSpPr>
@@ -3041,7 +3076,7 @@
       </p:sp>
       <p:sp>
         <p:nvSpPr>
-          <p:cNvPr id="22" name="Shape 18"/>
+          <p:cNvPr id="23" name="Shape 18"/>
           <p:cNvSpPr/>
           <p:nvPr/>
         </p:nvSpPr>
@@ -3066,7 +3101,7 @@
       </p:sp>
       <p:sp>
         <p:nvSpPr>
-          <p:cNvPr id="23" name="Shape 19"/>
+          <p:cNvPr id="24" name="Shape 19"/>
           <p:cNvSpPr/>
           <p:nvPr/>
         </p:nvSpPr>
@@ -3086,7 +3121,7 @@
       </p:sp>
       <p:sp>
         <p:nvSpPr>
-          <p:cNvPr id="24" name="Text 20"/>
+          <p:cNvPr id="25" name="Text 20"/>
           <p:cNvSpPr/>
           <p:nvPr/>
         </p:nvSpPr>
@@ -3125,7 +3160,7 @@
       </p:sp>
       <p:sp>
         <p:nvSpPr>
-          <p:cNvPr id="25" name="Text 21"/>
+          <p:cNvPr id="26" name="Text 21"/>
           <p:cNvSpPr/>
           <p:nvPr/>
         </p:nvSpPr>
@@ -3164,7 +3199,7 @@
       </p:sp>
       <p:sp>
         <p:nvSpPr>
-          <p:cNvPr id="26" name="Shape 22"/>
+          <p:cNvPr id="27" name="Shape 22"/>
           <p:cNvSpPr/>
           <p:nvPr/>
         </p:nvSpPr>
@@ -3189,7 +3224,7 @@
       </p:sp>
       <p:sp>
         <p:nvSpPr>
-          <p:cNvPr id="27" name="Shape 23"/>
+          <p:cNvPr id="28" name="Shape 23"/>
           <p:cNvSpPr/>
           <p:nvPr/>
         </p:nvSpPr>
@@ -3209,7 +3244,7 @@
       </p:sp>
       <p:sp>
         <p:nvSpPr>
-          <p:cNvPr id="28" name="Text 24"/>
+          <p:cNvPr id="29" name="Text 24"/>
           <p:cNvSpPr/>
           <p:nvPr/>
         </p:nvSpPr>
@@ -3248,7 +3283,7 @@
       </p:sp>
       <p:sp>
         <p:nvSpPr>
-          <p:cNvPr id="29" name="Text 25"/>
+          <p:cNvPr id="30" name="Text 25"/>
           <p:cNvSpPr/>
           <p:nvPr/>
         </p:nvSpPr>
@@ -3287,7 +3322,7 @@
       </p:sp>
       <p:sp>
         <p:nvSpPr>
-          <p:cNvPr id="30" name="Text 26"/>
+          <p:cNvPr id="31" name="Text 26"/>
           <p:cNvSpPr/>
           <p:nvPr/>
         </p:nvSpPr>
@@ -3326,7 +3361,7 @@
       </p:sp>
       <p:sp>
         <p:nvSpPr>
-          <p:cNvPr id="31" name="Text 27"/>
+          <p:cNvPr id="32" name="Text 27"/>
           <p:cNvSpPr/>
           <p:nvPr/>
         </p:nvSpPr>
@@ -3515,7 +3550,7 @@
       </p:sp>
       <p:sp>
         <p:nvSpPr>
-          <p:cNvPr id="6" name="Shape 4"/>
+          <p:cNvPr id="7" name="Shape 4"/>
           <p:cNvSpPr/>
           <p:nvPr/>
         </p:nvSpPr>
@@ -3547,7 +3582,7 @@
       </p:sp>
       <p:sp>
         <p:nvSpPr>
-          <p:cNvPr id="7" name="Shape 5"/>
+          <p:cNvPr id="8" name="Shape 5"/>
           <p:cNvSpPr/>
           <p:nvPr/>
         </p:nvSpPr>
@@ -3567,7 +3602,7 @@
       </p:sp>
       <p:sp>
         <p:nvSpPr>
-          <p:cNvPr id="8" name="Text 6"/>
+          <p:cNvPr id="9" name="Text 6"/>
           <p:cNvSpPr/>
           <p:nvPr/>
         </p:nvSpPr>
@@ -3606,7 +3641,7 @@
       </p:sp>
       <p:sp>
         <p:nvSpPr>
-          <p:cNvPr id="9" name="Text 7"/>
+          <p:cNvPr id="10" name="Text 7"/>
           <p:cNvSpPr/>
           <p:nvPr/>
         </p:nvSpPr>
@@ -3645,7 +3680,7 @@
       </p:sp>
       <p:sp>
         <p:nvSpPr>
-          <p:cNvPr id="10" name="Shape 8"/>
+          <p:cNvPr id="11" name="Shape 8"/>
           <p:cNvSpPr/>
           <p:nvPr/>
         </p:nvSpPr>
@@ -3677,7 +3712,7 @@
       </p:sp>
       <p:sp>
         <p:nvSpPr>
-          <p:cNvPr id="11" name="Shape 9"/>
+          <p:cNvPr id="12" name="Shape 9"/>
           <p:cNvSpPr/>
           <p:nvPr/>
         </p:nvSpPr>
@@ -3697,7 +3732,7 @@
       </p:sp>
       <p:sp>
         <p:nvSpPr>
-          <p:cNvPr id="12" name="Text 10"/>
+          <p:cNvPr id="13" name="Text 10"/>
           <p:cNvSpPr/>
           <p:nvPr/>
         </p:nvSpPr>
@@ -3736,7 +3771,7 @@
       </p:sp>
       <p:sp>
         <p:nvSpPr>
-          <p:cNvPr id="13" name="Text 11"/>
+          <p:cNvPr id="14" name="Text 11"/>
           <p:cNvSpPr/>
           <p:nvPr/>
         </p:nvSpPr>
@@ -3775,7 +3810,7 @@
       </p:sp>
       <p:sp>
         <p:nvSpPr>
-          <p:cNvPr id="14" name="Shape 12"/>
+          <p:cNvPr id="15" name="Shape 12"/>
           <p:cNvSpPr/>
           <p:nvPr/>
         </p:nvSpPr>
@@ -3807,7 +3842,7 @@
       </p:sp>
       <p:sp>
         <p:nvSpPr>
-          <p:cNvPr id="15" name="Shape 13"/>
+          <p:cNvPr id="16" name="Shape 13"/>
           <p:cNvSpPr/>
           <p:nvPr/>
         </p:nvSpPr>
@@ -3827,7 +3862,7 @@
       </p:sp>
       <p:sp>
         <p:nvSpPr>
-          <p:cNvPr id="16" name="Text 14"/>
+          <p:cNvPr id="17" name="Text 14"/>
           <p:cNvSpPr/>
           <p:nvPr/>
         </p:nvSpPr>
@@ -3866,7 +3901,7 @@
       </p:sp>
       <p:sp>
         <p:nvSpPr>
-          <p:cNvPr id="17" name="Text 15"/>
+          <p:cNvPr id="18" name="Text 15"/>
           <p:cNvSpPr/>
           <p:nvPr/>
         </p:nvSpPr>
@@ -3905,7 +3940,7 @@
       </p:sp>
       <p:sp>
         <p:nvSpPr>
-          <p:cNvPr id="18" name="Text 16"/>
+          <p:cNvPr id="19" name="Text 16"/>
           <p:cNvSpPr/>
           <p:nvPr/>
         </p:nvSpPr>
@@ -3944,7 +3979,7 @@
       </p:sp>
       <p:sp>
         <p:nvSpPr>
-          <p:cNvPr id="19" name="Text 17"/>
+          <p:cNvPr id="20" name="Text 17"/>
           <p:cNvSpPr/>
           <p:nvPr/>
         </p:nvSpPr>
@@ -5267,7 +5302,7 @@
       </p:graphicFrame>
       <p:sp>
         <p:nvSpPr>
-          <p:cNvPr id="7" name="Text 4"/>
+          <p:cNvPr id="8" name="Text 4"/>
           <p:cNvSpPr/>
           <p:nvPr/>
         </p:nvSpPr>
@@ -5306,7 +5341,7 @@
       </p:sp>
       <p:sp>
         <p:nvSpPr>
-          <p:cNvPr id="8" name="Text 5"/>
+          <p:cNvPr id="9" name="Text 5"/>
           <p:cNvSpPr/>
           <p:nvPr/>
         </p:nvSpPr>
@@ -6119,7 +6154,7 @@
       </p:sp>
       <p:sp>
         <p:nvSpPr>
-          <p:cNvPr id="6" name="Shape 4"/>
+          <p:cNvPr id="7" name="Shape 4"/>
           <p:cNvSpPr/>
           <p:nvPr/>
         </p:nvSpPr>
@@ -6151,7 +6186,7 @@
       </p:sp>
       <p:sp>
         <p:nvSpPr>
-          <p:cNvPr id="7" name="Text 5"/>
+          <p:cNvPr id="8" name="Text 5"/>
           <p:cNvSpPr/>
           <p:nvPr/>
         </p:nvSpPr>
@@ -6190,7 +6225,7 @@
       </p:sp>
       <p:sp>
         <p:nvSpPr>
-          <p:cNvPr id="8" name="Text 6"/>
+          <p:cNvPr id="9" name="Text 6"/>
           <p:cNvSpPr/>
           <p:nvPr/>
         </p:nvSpPr>
@@ -6275,7 +6310,7 @@
       </p:sp>
       <p:sp>
         <p:nvSpPr>
-          <p:cNvPr id="9" name="Shape 7"/>
+          <p:cNvPr id="10" name="Shape 7"/>
           <p:cNvSpPr/>
           <p:nvPr/>
         </p:nvSpPr>
@@ -6307,7 +6342,7 @@
       </p:sp>
       <p:sp>
         <p:nvSpPr>
-          <p:cNvPr id="10" name="Text 8"/>
+          <p:cNvPr id="11" name="Text 8"/>
           <p:cNvSpPr/>
           <p:nvPr/>
         </p:nvSpPr>
@@ -6910,7 +6945,7 @@
       </p:graphicFrame>
       <p:sp>
         <p:nvSpPr>
-          <p:cNvPr id="12" name="Shape 9"/>
+          <p:cNvPr id="13" name="Shape 9"/>
           <p:cNvSpPr/>
           <p:nvPr/>
         </p:nvSpPr>
@@ -6942,7 +6977,7 @@
       </p:sp>
       <p:sp>
         <p:nvSpPr>
-          <p:cNvPr id="13" name="Text 10"/>
+          <p:cNvPr id="14" name="Text 10"/>
           <p:cNvSpPr/>
           <p:nvPr/>
         </p:nvSpPr>
@@ -6981,7 +7016,7 @@
       </p:sp>
       <p:sp>
         <p:nvSpPr>
-          <p:cNvPr id="14" name="Shape 11"/>
+          <p:cNvPr id="15" name="Shape 11"/>
           <p:cNvSpPr/>
           <p:nvPr/>
         </p:nvSpPr>
@@ -7006,7 +7041,7 @@
       </p:sp>
       <p:sp>
         <p:nvSpPr>
-          <p:cNvPr id="15" name="Text 12"/>
+          <p:cNvPr id="16" name="Text 12"/>
           <p:cNvSpPr/>
           <p:nvPr/>
         </p:nvSpPr>
@@ -7045,7 +7080,7 @@
       </p:sp>
       <p:sp>
         <p:nvSpPr>
-          <p:cNvPr id="16" name="Text 13"/>
+          <p:cNvPr id="17" name="Text 13"/>
           <p:cNvSpPr/>
           <p:nvPr/>
         </p:nvSpPr>
@@ -7084,7 +7119,7 @@
       </p:sp>
       <p:sp>
         <p:nvSpPr>
-          <p:cNvPr id="17" name="Shape 14"/>
+          <p:cNvPr id="18" name="Shape 14"/>
           <p:cNvSpPr/>
           <p:nvPr/>
         </p:nvSpPr>
@@ -7109,7 +7144,7 @@
       </p:sp>
       <p:sp>
         <p:nvSpPr>
-          <p:cNvPr id="18" name="Text 15"/>
+          <p:cNvPr id="19" name="Text 15"/>
           <p:cNvSpPr/>
           <p:nvPr/>
         </p:nvSpPr>
@@ -7148,7 +7183,7 @@
       </p:sp>
       <p:sp>
         <p:nvSpPr>
-          <p:cNvPr id="19" name="Text 16"/>
+          <p:cNvPr id="20" name="Text 16"/>
           <p:cNvSpPr/>
           <p:nvPr/>
         </p:nvSpPr>
@@ -7187,7 +7222,7 @@
       </p:sp>
       <p:sp>
         <p:nvSpPr>
-          <p:cNvPr id="20" name="Shape 17"/>
+          <p:cNvPr id="21" name="Shape 17"/>
           <p:cNvSpPr/>
           <p:nvPr/>
         </p:nvSpPr>
@@ -7212,7 +7247,7 @@
       </p:sp>
       <p:sp>
         <p:nvSpPr>
-          <p:cNvPr id="21" name="Text 18"/>
+          <p:cNvPr id="22" name="Text 18"/>
           <p:cNvSpPr/>
           <p:nvPr/>
         </p:nvSpPr>
@@ -7251,7 +7286,7 @@
       </p:sp>
       <p:sp>
         <p:nvSpPr>
-          <p:cNvPr id="22" name="Text 19"/>
+          <p:cNvPr id="23" name="Text 19"/>
           <p:cNvSpPr/>
           <p:nvPr/>
         </p:nvSpPr>
@@ -7290,7 +7325,7 @@
       </p:sp>
       <p:sp>
         <p:nvSpPr>
-          <p:cNvPr id="23" name="Shape 20"/>
+          <p:cNvPr id="24" name="Shape 20"/>
           <p:cNvSpPr/>
           <p:nvPr/>
         </p:nvSpPr>
@@ -7315,7 +7350,7 @@
       </p:sp>
       <p:sp>
         <p:nvSpPr>
-          <p:cNvPr id="24" name="Text 21"/>
+          <p:cNvPr id="25" name="Text 21"/>
           <p:cNvSpPr/>
           <p:nvPr/>
         </p:nvSpPr>
@@ -7354,7 +7389,7 @@
       </p:sp>
       <p:sp>
         <p:nvSpPr>
-          <p:cNvPr id="25" name="Text 22"/>
+          <p:cNvPr id="26" name="Text 22"/>
           <p:cNvSpPr/>
           <p:nvPr/>
         </p:nvSpPr>
@@ -7393,7 +7428,7 @@
       </p:sp>
       <p:sp>
         <p:nvSpPr>
-          <p:cNvPr id="26" name="Shape 23"/>
+          <p:cNvPr id="27" name="Shape 23"/>
           <p:cNvSpPr/>
           <p:nvPr/>
         </p:nvSpPr>
@@ -7418,7 +7453,7 @@
       </p:sp>
       <p:sp>
         <p:nvSpPr>
-          <p:cNvPr id="27" name="Text 24"/>
+          <p:cNvPr id="28" name="Text 24"/>
           <p:cNvSpPr/>
           <p:nvPr/>
         </p:nvSpPr>
@@ -7457,7 +7492,7 @@
       </p:sp>
       <p:sp>
         <p:nvSpPr>
-          <p:cNvPr id="28" name="Text 25"/>
+          <p:cNvPr id="29" name="Text 25"/>
           <p:cNvSpPr/>
           <p:nvPr/>
         </p:nvSpPr>
@@ -7496,7 +7531,7 @@
       </p:sp>
       <p:sp>
         <p:nvSpPr>
-          <p:cNvPr id="29" name="Shape 26"/>
+          <p:cNvPr id="30" name="Shape 26"/>
           <p:cNvSpPr/>
           <p:nvPr/>
         </p:nvSpPr>
@@ -7521,7 +7556,7 @@
       </p:sp>
       <p:sp>
         <p:nvSpPr>
-          <p:cNvPr id="30" name="Text 27"/>
+          <p:cNvPr id="31" name="Text 27"/>
           <p:cNvSpPr/>
           <p:nvPr/>
         </p:nvSpPr>
@@ -7560,7 +7595,7 @@
       </p:sp>
       <p:sp>
         <p:nvSpPr>
-          <p:cNvPr id="31" name="Text 28"/>
+          <p:cNvPr id="32" name="Text 28"/>
           <p:cNvSpPr/>
           <p:nvPr/>
         </p:nvSpPr>
@@ -7599,7 +7634,7 @@
       </p:sp>
       <p:sp>
         <p:nvSpPr>
-          <p:cNvPr id="32" name="Text 29"/>
+          <p:cNvPr id="33" name="Text 29"/>
           <p:cNvSpPr/>
           <p:nvPr/>
         </p:nvSpPr>
@@ -7638,7 +7673,7 @@
       </p:sp>
       <p:sp>
         <p:nvSpPr>
-          <p:cNvPr id="33" name="Text 30"/>
+          <p:cNvPr id="34" name="Text 30"/>
           <p:cNvSpPr/>
           <p:nvPr/>
         </p:nvSpPr>
@@ -7827,7 +7862,7 @@
       </p:sp>
       <p:sp>
         <p:nvSpPr>
-          <p:cNvPr id="6" name="Shape 4"/>
+          <p:cNvPr id="7" name="Shape 4"/>
           <p:cNvSpPr/>
           <p:nvPr/>
         </p:nvSpPr>
@@ -7852,7 +7887,7 @@
       </p:sp>
       <p:sp>
         <p:nvSpPr>
-          <p:cNvPr id="7" name="Text 5"/>
+          <p:cNvPr id="8" name="Text 5"/>
           <p:cNvSpPr/>
           <p:nvPr/>
         </p:nvSpPr>
@@ -7891,7 +7926,7 @@
       </p:sp>
       <p:sp>
         <p:nvSpPr>
-          <p:cNvPr id="8" name="Shape 6"/>
+          <p:cNvPr id="9" name="Shape 6"/>
           <p:cNvSpPr/>
           <p:nvPr/>
         </p:nvSpPr>
@@ -7913,7 +7948,7 @@
       </p:sp>
       <p:sp>
         <p:nvSpPr>
-          <p:cNvPr id="9" name="Text 7"/>
+          <p:cNvPr id="10" name="Text 7"/>
           <p:cNvSpPr/>
           <p:nvPr/>
         </p:nvSpPr>
@@ -7969,7 +8004,7 @@
       </p:sp>
       <p:sp>
         <p:nvSpPr>
-          <p:cNvPr id="10" name="Shape 8"/>
+          <p:cNvPr id="11" name="Shape 8"/>
           <p:cNvSpPr/>
           <p:nvPr/>
         </p:nvSpPr>
@@ -7993,7 +8028,7 @@
       </p:sp>
       <p:sp>
         <p:nvSpPr>
-          <p:cNvPr id="11" name="Text 9"/>
+          <p:cNvPr id="12" name="Text 9"/>
           <p:cNvSpPr/>
           <p:nvPr/>
         </p:nvSpPr>
@@ -8032,7 +8067,7 @@
       </p:sp>
       <p:sp>
         <p:nvSpPr>
-          <p:cNvPr id="12" name="Shape 10"/>
+          <p:cNvPr id="13" name="Shape 10"/>
           <p:cNvSpPr/>
           <p:nvPr/>
         </p:nvSpPr>
@@ -8059,7 +8094,7 @@
       </p:sp>
       <p:sp>
         <p:nvSpPr>
-          <p:cNvPr id="13" name="Text 11"/>
+          <p:cNvPr id="14" name="Text 11"/>
           <p:cNvSpPr/>
           <p:nvPr/>
         </p:nvSpPr>
@@ -8098,7 +8133,7 @@
       </p:sp>
       <p:sp>
         <p:nvSpPr>
-          <p:cNvPr id="14" name="Text 12"/>
+          <p:cNvPr id="15" name="Text 12"/>
           <p:cNvSpPr/>
           <p:nvPr/>
         </p:nvSpPr>
@@ -8156,7 +8191,7 @@
       </p:sp>
       <p:sp>
         <p:nvSpPr>
-          <p:cNvPr id="15" name="Shape 13"/>
+          <p:cNvPr id="16" name="Shape 13"/>
           <p:cNvSpPr/>
           <p:nvPr/>
         </p:nvSpPr>
@@ -8180,7 +8215,7 @@
       </p:sp>
       <p:sp>
         <p:nvSpPr>
-          <p:cNvPr id="16" name="Text 14"/>
+          <p:cNvPr id="17" name="Text 14"/>
           <p:cNvSpPr/>
           <p:nvPr/>
         </p:nvSpPr>
@@ -8219,7 +8254,7 @@
       </p:sp>
       <p:sp>
         <p:nvSpPr>
-          <p:cNvPr id="17" name="Shape 15"/>
+          <p:cNvPr id="18" name="Shape 15"/>
           <p:cNvSpPr/>
           <p:nvPr/>
         </p:nvSpPr>
@@ -8246,7 +8281,7 @@
       </p:sp>
       <p:sp>
         <p:nvSpPr>
-          <p:cNvPr id="18" name="Text 16"/>
+          <p:cNvPr id="19" name="Text 16"/>
           <p:cNvSpPr/>
           <p:nvPr/>
         </p:nvSpPr>
@@ -8285,7 +8320,7 @@
       </p:sp>
       <p:sp>
         <p:nvSpPr>
-          <p:cNvPr id="19" name="Shape 17"/>
+          <p:cNvPr id="20" name="Shape 17"/>
           <p:cNvSpPr/>
           <p:nvPr/>
         </p:nvSpPr>
@@ -8310,7 +8345,7 @@
       </p:sp>
       <p:sp>
         <p:nvSpPr>
-          <p:cNvPr id="20" name="Text 18"/>
+          <p:cNvPr id="21" name="Text 18"/>
           <p:cNvSpPr/>
           <p:nvPr/>
         </p:nvSpPr>
@@ -8349,7 +8384,7 @@
       </p:sp>
       <p:sp>
         <p:nvSpPr>
-          <p:cNvPr id="21" name="Shape 19"/>
+          <p:cNvPr id="22" name="Shape 19"/>
           <p:cNvSpPr/>
           <p:nvPr/>
         </p:nvSpPr>
@@ -8374,7 +8409,7 @@
       </p:sp>
       <p:sp>
         <p:nvSpPr>
-          <p:cNvPr id="22" name="Text 20"/>
+          <p:cNvPr id="23" name="Text 20"/>
           <p:cNvSpPr/>
           <p:nvPr/>
         </p:nvSpPr>
@@ -8413,7 +8448,7 @@
       </p:sp>
       <p:sp>
         <p:nvSpPr>
-          <p:cNvPr id="23" name="Text 21"/>
+          <p:cNvPr id="24" name="Text 21"/>
           <p:cNvSpPr/>
           <p:nvPr/>
         </p:nvSpPr>
@@ -8452,7 +8487,7 @@
       </p:sp>
       <p:sp>
         <p:nvSpPr>
-          <p:cNvPr id="24" name="Shape 22"/>
+          <p:cNvPr id="25" name="Shape 22"/>
           <p:cNvSpPr/>
           <p:nvPr/>
         </p:nvSpPr>
@@ -8476,7 +8511,7 @@
       </p:sp>
       <p:sp>
         <p:nvSpPr>
-          <p:cNvPr id="25" name="Shape 23"/>
+          <p:cNvPr id="26" name="Shape 23"/>
           <p:cNvSpPr/>
           <p:nvPr/>
         </p:nvSpPr>
@@ -8498,7 +8533,7 @@
       </p:sp>
       <p:sp>
         <p:nvSpPr>
-          <p:cNvPr id="26" name="Text 24"/>
+          <p:cNvPr id="27" name="Text 24"/>
           <p:cNvSpPr/>
           <p:nvPr/>
         </p:nvSpPr>
@@ -8537,7 +8572,7 @@
       </p:sp>
       <p:sp>
         <p:nvSpPr>
-          <p:cNvPr id="27" name="Text 25"/>
+          <p:cNvPr id="28" name="Text 25"/>
           <p:cNvSpPr/>
           <p:nvPr/>
         </p:nvSpPr>
@@ -8610,7 +8645,7 @@
       </p:sp>
       <p:sp>
         <p:nvSpPr>
-          <p:cNvPr id="28" name="Shape 26"/>
+          <p:cNvPr id="29" name="Shape 26"/>
           <p:cNvSpPr/>
           <p:nvPr/>
         </p:nvSpPr>
@@ -8637,7 +8672,7 @@
       </p:sp>
       <p:sp>
         <p:nvSpPr>
-          <p:cNvPr id="29" name="Text 27"/>
+          <p:cNvPr id="30" name="Text 27"/>
           <p:cNvSpPr/>
           <p:nvPr/>
         </p:nvSpPr>
@@ -8676,7 +8711,7 @@
       </p:sp>
       <p:sp>
         <p:nvSpPr>
-          <p:cNvPr id="30" name="Text 28"/>
+          <p:cNvPr id="31" name="Text 28"/>
           <p:cNvSpPr/>
           <p:nvPr/>
         </p:nvSpPr>
@@ -8778,7 +8813,7 @@
       </p:sp>
       <p:sp>
         <p:nvSpPr>
-          <p:cNvPr id="31" name="Text 29"/>
+          <p:cNvPr id="32" name="Text 29"/>
           <p:cNvSpPr/>
           <p:nvPr/>
         </p:nvSpPr>
@@ -8817,7 +8852,7 @@
       </p:sp>
       <p:sp>
         <p:nvSpPr>
-          <p:cNvPr id="32" name="Text 30"/>
+          <p:cNvPr id="33" name="Text 30"/>
           <p:cNvSpPr/>
           <p:nvPr/>
         </p:nvSpPr>
@@ -8856,7 +8891,7 @@
       </p:sp>
       <p:sp>
         <p:nvSpPr>
-          <p:cNvPr id="33" name="Text 31"/>
+          <p:cNvPr id="34" name="Text 31"/>
           <p:cNvSpPr/>
           <p:nvPr/>
         </p:nvSpPr>
@@ -9045,7 +9080,7 @@
       </p:sp>
       <p:sp>
         <p:nvSpPr>
-          <p:cNvPr id="6" name="Shape 4"/>
+          <p:cNvPr id="7" name="Shape 4"/>
           <p:cNvSpPr/>
           <p:nvPr/>
         </p:nvSpPr>
@@ -9077,7 +9112,7 @@
       </p:sp>
       <p:sp>
         <p:nvSpPr>
-          <p:cNvPr id="7" name="Shape 5"/>
+          <p:cNvPr id="8" name="Shape 5"/>
           <p:cNvSpPr/>
           <p:nvPr/>
         </p:nvSpPr>
@@ -9097,7 +9132,7 @@
       </p:sp>
       <p:sp>
         <p:nvSpPr>
-          <p:cNvPr id="8" name="Text 6"/>
+          <p:cNvPr id="9" name="Text 6"/>
           <p:cNvSpPr/>
           <p:nvPr/>
         </p:nvSpPr>
@@ -9136,7 +9171,7 @@
       </p:sp>
       <p:sp>
         <p:nvSpPr>
-          <p:cNvPr id="9" name="Text 7"/>
+          <p:cNvPr id="10" name="Text 7"/>
           <p:cNvSpPr/>
           <p:nvPr/>
         </p:nvSpPr>
@@ -9242,7 +9277,7 @@
       </p:sp>
       <p:sp>
         <p:nvSpPr>
-          <p:cNvPr id="10" name="Shape 8"/>
+          <p:cNvPr id="11" name="Shape 8"/>
           <p:cNvSpPr/>
           <p:nvPr/>
         </p:nvSpPr>
@@ -9274,7 +9309,7 @@
       </p:sp>
       <p:sp>
         <p:nvSpPr>
-          <p:cNvPr id="11" name="Shape 9"/>
+          <p:cNvPr id="12" name="Shape 9"/>
           <p:cNvSpPr/>
           <p:nvPr/>
         </p:nvSpPr>
@@ -9294,7 +9329,7 @@
       </p:sp>
       <p:sp>
         <p:nvSpPr>
-          <p:cNvPr id="12" name="Text 10"/>
+          <p:cNvPr id="13" name="Text 10"/>
           <p:cNvSpPr/>
           <p:nvPr/>
         </p:nvSpPr>
@@ -9333,7 +9368,7 @@
       </p:sp>
       <p:sp>
         <p:nvSpPr>
-          <p:cNvPr id="13" name="Text 11"/>
+          <p:cNvPr id="14" name="Text 11"/>
           <p:cNvSpPr/>
           <p:nvPr/>
         </p:nvSpPr>
@@ -9439,7 +9474,7 @@
       </p:sp>
       <p:sp>
         <p:nvSpPr>
-          <p:cNvPr id="14" name="Shape 12"/>
+          <p:cNvPr id="15" name="Shape 12"/>
           <p:cNvSpPr/>
           <p:nvPr/>
         </p:nvSpPr>
@@ -9471,7 +9506,7 @@
       </p:sp>
       <p:sp>
         <p:nvSpPr>
-          <p:cNvPr id="15" name="Shape 13"/>
+          <p:cNvPr id="16" name="Shape 13"/>
           <p:cNvSpPr/>
           <p:nvPr/>
         </p:nvSpPr>
@@ -9491,7 +9526,7 @@
       </p:sp>
       <p:sp>
         <p:nvSpPr>
-          <p:cNvPr id="16" name="Text 14"/>
+          <p:cNvPr id="17" name="Text 14"/>
           <p:cNvSpPr/>
           <p:nvPr/>
         </p:nvSpPr>
@@ -9530,7 +9565,7 @@
       </p:sp>
       <p:sp>
         <p:nvSpPr>
-          <p:cNvPr id="17" name="Text 15"/>
+          <p:cNvPr id="18" name="Text 15"/>
           <p:cNvSpPr/>
           <p:nvPr/>
         </p:nvSpPr>
@@ -9636,7 +9671,7 @@
       </p:sp>
       <p:sp>
         <p:nvSpPr>
-          <p:cNvPr id="18" name="Shape 16"/>
+          <p:cNvPr id="19" name="Shape 16"/>
           <p:cNvSpPr/>
           <p:nvPr/>
         </p:nvSpPr>
@@ -9668,7 +9703,7 @@
       </p:sp>
       <p:sp>
         <p:nvSpPr>
-          <p:cNvPr id="19" name="Text 17"/>
+          <p:cNvPr id="20" name="Text 17"/>
           <p:cNvSpPr/>
           <p:nvPr/>
         </p:nvSpPr>
@@ -9707,7 +9742,7 @@
       </p:sp>
       <p:sp>
         <p:nvSpPr>
-          <p:cNvPr id="20" name="Text 18"/>
+          <p:cNvPr id="21" name="Text 18"/>
           <p:cNvSpPr/>
           <p:nvPr/>
         </p:nvSpPr>
@@ -9792,7 +9827,7 @@
       </p:sp>
       <p:sp>
         <p:nvSpPr>
-          <p:cNvPr id="21" name="Text 19"/>
+          <p:cNvPr id="22" name="Text 19"/>
           <p:cNvSpPr/>
           <p:nvPr/>
         </p:nvSpPr>
@@ -9831,7 +9866,7 @@
       </p:sp>
       <p:sp>
         <p:nvSpPr>
-          <p:cNvPr id="22" name="Text 20"/>
+          <p:cNvPr id="23" name="Text 20"/>
           <p:cNvSpPr/>
           <p:nvPr/>
         </p:nvSpPr>
@@ -10020,7 +10055,7 @@
       </p:sp>
       <p:sp>
         <p:nvSpPr>
-          <p:cNvPr id="6" name="Shape 4"/>
+          <p:cNvPr id="7" name="Shape 4"/>
           <p:cNvSpPr/>
           <p:nvPr/>
         </p:nvSpPr>
@@ -10052,7 +10087,7 @@
       </p:sp>
       <p:sp>
         <p:nvSpPr>
-          <p:cNvPr id="7" name="Text 5"/>
+          <p:cNvPr id="8" name="Text 5"/>
           <p:cNvSpPr/>
           <p:nvPr/>
         </p:nvSpPr>
@@ -10091,7 +10126,7 @@
       </p:sp>
       <p:sp>
         <p:nvSpPr>
-          <p:cNvPr id="8" name="Shape 6"/>
+          <p:cNvPr id="9" name="Shape 6"/>
           <p:cNvSpPr/>
           <p:nvPr/>
         </p:nvSpPr>
@@ -10111,7 +10146,7 @@
       </p:sp>
       <p:sp>
         <p:nvSpPr>
-          <p:cNvPr id="9" name="Text 7"/>
+          <p:cNvPr id="10" name="Text 7"/>
           <p:cNvSpPr/>
           <p:nvPr/>
         </p:nvSpPr>
@@ -10273,7 +10308,7 @@
       </p:sp>
       <p:sp>
         <p:nvSpPr>
-          <p:cNvPr id="10" name="Shape 8"/>
+          <p:cNvPr id="11" name="Shape 8"/>
           <p:cNvSpPr/>
           <p:nvPr/>
         </p:nvSpPr>
@@ -10305,7 +10340,7 @@
       </p:sp>
       <p:sp>
         <p:nvSpPr>
-          <p:cNvPr id="11" name="Text 9"/>
+          <p:cNvPr id="12" name="Text 9"/>
           <p:cNvSpPr/>
           <p:nvPr/>
         </p:nvSpPr>
@@ -10344,7 +10379,7 @@
       </p:sp>
       <p:sp>
         <p:nvSpPr>
-          <p:cNvPr id="12" name="Shape 10"/>
+          <p:cNvPr id="13" name="Shape 10"/>
           <p:cNvSpPr/>
           <p:nvPr/>
         </p:nvSpPr>
@@ -10364,7 +10399,7 @@
       </p:sp>
       <p:sp>
         <p:nvSpPr>
-          <p:cNvPr id="13" name="Text 11"/>
+          <p:cNvPr id="14" name="Text 11"/>
           <p:cNvSpPr/>
           <p:nvPr/>
         </p:nvSpPr>
@@ -10526,7 +10561,7 @@
       </p:sp>
       <p:sp>
         <p:nvSpPr>
-          <p:cNvPr id="14" name="Shape 12"/>
+          <p:cNvPr id="15" name="Shape 12"/>
           <p:cNvSpPr/>
           <p:nvPr/>
         </p:nvSpPr>
@@ -10558,7 +10593,7 @@
       </p:sp>
       <p:sp>
         <p:nvSpPr>
-          <p:cNvPr id="15" name="Text 13"/>
+          <p:cNvPr id="16" name="Text 13"/>
           <p:cNvSpPr/>
           <p:nvPr/>
         </p:nvSpPr>
@@ -10597,7 +10632,7 @@
       </p:sp>
       <p:sp>
         <p:nvSpPr>
-          <p:cNvPr id="16" name="Text 14"/>
+          <p:cNvPr id="17" name="Text 14"/>
           <p:cNvSpPr/>
           <p:nvPr/>
         </p:nvSpPr>
@@ -10636,7 +10671,7 @@
       </p:sp>
       <p:sp>
         <p:nvSpPr>
-          <p:cNvPr id="17" name="Shape 15"/>
+          <p:cNvPr id="18" name="Shape 15"/>
           <p:cNvSpPr/>
           <p:nvPr/>
         </p:nvSpPr>
@@ -10668,7 +10703,7 @@
       </p:sp>
       <p:sp>
         <p:nvSpPr>
-          <p:cNvPr id="18" name="Text 16"/>
+          <p:cNvPr id="19" name="Text 16"/>
           <p:cNvSpPr/>
           <p:nvPr/>
         </p:nvSpPr>
@@ -10707,7 +10742,7 @@
       </p:sp>
       <p:sp>
         <p:nvSpPr>
-          <p:cNvPr id="19" name="Text 17"/>
+          <p:cNvPr id="20" name="Text 17"/>
           <p:cNvSpPr/>
           <p:nvPr/>
         </p:nvSpPr>
@@ -10746,7 +10781,7 @@
       </p:sp>
       <p:sp>
         <p:nvSpPr>
-          <p:cNvPr id="20" name="Shape 18"/>
+          <p:cNvPr id="21" name="Shape 18"/>
           <p:cNvSpPr/>
           <p:nvPr/>
         </p:nvSpPr>
@@ -10778,7 +10813,7 @@
       </p:sp>
       <p:sp>
         <p:nvSpPr>
-          <p:cNvPr id="21" name="Text 19"/>
+          <p:cNvPr id="22" name="Text 19"/>
           <p:cNvSpPr/>
           <p:nvPr/>
         </p:nvSpPr>
@@ -10817,7 +10852,7 @@
       </p:sp>
       <p:sp>
         <p:nvSpPr>
-          <p:cNvPr id="22" name="Text 20"/>
+          <p:cNvPr id="23" name="Text 20"/>
           <p:cNvSpPr/>
           <p:nvPr/>
         </p:nvSpPr>
@@ -10856,7 +10891,7 @@
       </p:sp>
       <p:sp>
         <p:nvSpPr>
-          <p:cNvPr id="23" name="Text 21"/>
+          <p:cNvPr id="24" name="Text 21"/>
           <p:cNvSpPr/>
           <p:nvPr/>
         </p:nvSpPr>
@@ -10895,7 +10930,7 @@
       </p:sp>
       <p:sp>
         <p:nvSpPr>
-          <p:cNvPr id="24" name="Text 22"/>
+          <p:cNvPr id="25" name="Text 22"/>
           <p:cNvSpPr/>
           <p:nvPr/>
         </p:nvSpPr>
@@ -11084,7 +11119,7 @@
       </p:sp>
       <p:sp>
         <p:nvSpPr>
-          <p:cNvPr id="6" name="Shape 4"/>
+          <p:cNvPr id="7" name="Shape 4"/>
           <p:cNvSpPr/>
           <p:nvPr/>
         </p:nvSpPr>
@@ -11116,7 +11151,7 @@
       </p:sp>
       <p:sp>
         <p:nvSpPr>
-          <p:cNvPr id="7" name="Text 5"/>
+          <p:cNvPr id="8" name="Text 5"/>
           <p:cNvSpPr/>
           <p:nvPr/>
         </p:nvSpPr>
@@ -11155,7 +11190,7 @@
       </p:sp>
       <p:sp>
         <p:nvSpPr>
-          <p:cNvPr id="8" name="Shape 6"/>
+          <p:cNvPr id="9" name="Shape 6"/>
           <p:cNvSpPr/>
           <p:nvPr/>
         </p:nvSpPr>
@@ -11175,7 +11210,7 @@
       </p:sp>
       <p:sp>
         <p:nvSpPr>
-          <p:cNvPr id="9" name="Text 7"/>
+          <p:cNvPr id="10" name="Text 7"/>
           <p:cNvSpPr/>
           <p:nvPr/>
         </p:nvSpPr>
@@ -11231,7 +11266,7 @@
       </p:sp>
       <p:sp>
         <p:nvSpPr>
-          <p:cNvPr id="10" name="Text 8"/>
+          <p:cNvPr id="11" name="Text 8"/>
           <p:cNvSpPr/>
           <p:nvPr/>
         </p:nvSpPr>
@@ -11295,7 +11330,7 @@
       </p:sp>
       <p:sp>
         <p:nvSpPr>
-          <p:cNvPr id="11" name="Shape 9"/>
+          <p:cNvPr id="12" name="Shape 9"/>
           <p:cNvSpPr/>
           <p:nvPr/>
         </p:nvSpPr>
@@ -11327,7 +11362,7 @@
       </p:sp>
       <p:sp>
         <p:nvSpPr>
-          <p:cNvPr id="12" name="Text 10"/>
+          <p:cNvPr id="13" name="Text 10"/>
           <p:cNvSpPr/>
           <p:nvPr/>
         </p:nvSpPr>
@@ -11366,7 +11401,7 @@
       </p:sp>
       <p:sp>
         <p:nvSpPr>
-          <p:cNvPr id="13" name="Shape 11"/>
+          <p:cNvPr id="14" name="Shape 11"/>
           <p:cNvSpPr/>
           <p:nvPr/>
         </p:nvSpPr>
@@ -11386,7 +11421,7 @@
       </p:sp>
       <p:sp>
         <p:nvSpPr>
-          <p:cNvPr id="14" name="Text 12"/>
+          <p:cNvPr id="15" name="Text 12"/>
           <p:cNvSpPr/>
           <p:nvPr/>
         </p:nvSpPr>
@@ -11465,7 +11500,7 @@
       </p:sp>
       <p:sp>
         <p:nvSpPr>
-          <p:cNvPr id="15" name="Shape 13"/>
+          <p:cNvPr id="16" name="Shape 13"/>
           <p:cNvSpPr/>
           <p:nvPr/>
         </p:nvSpPr>
@@ -11497,7 +11532,7 @@
       </p:sp>
       <p:sp>
         <p:nvSpPr>
-          <p:cNvPr id="16" name="Text 14"/>
+          <p:cNvPr id="17" name="Text 14"/>
           <p:cNvSpPr/>
           <p:nvPr/>
         </p:nvSpPr>
@@ -11536,7 +11571,7 @@
       </p:sp>
       <p:sp>
         <p:nvSpPr>
-          <p:cNvPr id="17" name="Shape 15"/>
+          <p:cNvPr id="18" name="Shape 15"/>
           <p:cNvSpPr/>
           <p:nvPr/>
         </p:nvSpPr>
@@ -11556,7 +11591,7 @@
       </p:sp>
       <p:sp>
         <p:nvSpPr>
-          <p:cNvPr id="18" name="Text 16"/>
+          <p:cNvPr id="19" name="Text 16"/>
           <p:cNvSpPr/>
           <p:nvPr/>
         </p:nvSpPr>
@@ -11612,7 +11647,7 @@
       </p:sp>
       <p:sp>
         <p:nvSpPr>
-          <p:cNvPr id="19" name="Text 17"/>
+          <p:cNvPr id="20" name="Text 17"/>
           <p:cNvSpPr/>
           <p:nvPr/>
         </p:nvSpPr>
@@ -11651,7 +11686,7 @@
       </p:sp>
       <p:sp>
         <p:nvSpPr>
-          <p:cNvPr id="20" name="Text 18"/>
+          <p:cNvPr id="21" name="Text 18"/>
           <p:cNvSpPr/>
           <p:nvPr/>
         </p:nvSpPr>
@@ -11690,7 +11725,7 @@
       </p:sp>
       <p:sp>
         <p:nvSpPr>
-          <p:cNvPr id="21" name="Text 19"/>
+          <p:cNvPr id="22" name="Text 19"/>
           <p:cNvSpPr/>
           <p:nvPr/>
         </p:nvSpPr>
@@ -13235,7 +13270,7 @@
       </p:graphicFrame>
       <p:sp>
         <p:nvSpPr>
-          <p:cNvPr id="7" name="Shape 4"/>
+          <p:cNvPr id="8" name="Shape 4"/>
           <p:cNvSpPr/>
           <p:nvPr/>
         </p:nvSpPr>
@@ -13267,7 +13302,7 @@
       </p:sp>
       <p:sp>
         <p:nvSpPr>
-          <p:cNvPr id="8" name="Text 5"/>
+          <p:cNvPr id="9" name="Text 5"/>
           <p:cNvSpPr/>
           <p:nvPr/>
         </p:nvSpPr>
@@ -13306,7 +13341,7 @@
       </p:sp>
       <p:sp>
         <p:nvSpPr>
-          <p:cNvPr id="9" name="Text 6"/>
+          <p:cNvPr id="10" name="Text 6"/>
           <p:cNvSpPr/>
           <p:nvPr/>
         </p:nvSpPr>
@@ -13391,7 +13426,7 @@
       </p:sp>
       <p:sp>
         <p:nvSpPr>
-          <p:cNvPr id="10" name="Shape 7"/>
+          <p:cNvPr id="11" name="Shape 7"/>
           <p:cNvSpPr/>
           <p:nvPr/>
         </p:nvSpPr>
@@ -13423,7 +13458,7 @@
       </p:sp>
       <p:sp>
         <p:nvSpPr>
-          <p:cNvPr id="11" name="Text 8"/>
+          <p:cNvPr id="12" name="Text 8"/>
           <p:cNvSpPr/>
           <p:nvPr/>
         </p:nvSpPr>
@@ -13462,7 +13497,7 @@
       </p:sp>
       <p:sp>
         <p:nvSpPr>
-          <p:cNvPr id="12" name="Text 9"/>
+          <p:cNvPr id="13" name="Text 9"/>
           <p:cNvSpPr/>
           <p:nvPr/>
         </p:nvSpPr>
@@ -13547,7 +13582,7 @@
       </p:sp>
       <p:sp>
         <p:nvSpPr>
-          <p:cNvPr id="13" name="Text 10"/>
+          <p:cNvPr id="14" name="Text 10"/>
           <p:cNvSpPr/>
           <p:nvPr/>
         </p:nvSpPr>
@@ -13586,7 +13621,7 @@
       </p:sp>
       <p:sp>
         <p:nvSpPr>
-          <p:cNvPr id="14" name="Text 11"/>
+          <p:cNvPr id="15" name="Text 11"/>
           <p:cNvSpPr/>
           <p:nvPr/>
         </p:nvSpPr>
@@ -15129,7 +15164,7 @@
       </p:graphicFrame>
       <p:sp>
         <p:nvSpPr>
-          <p:cNvPr id="7" name="Shape 4"/>
+          <p:cNvPr id="8" name="Shape 4"/>
           <p:cNvSpPr/>
           <p:nvPr/>
         </p:nvSpPr>
@@ -15161,7 +15196,7 @@
       </p:sp>
       <p:sp>
         <p:nvSpPr>
-          <p:cNvPr id="8" name="Text 5"/>
+          <p:cNvPr id="9" name="Text 5"/>
           <p:cNvSpPr/>
           <p:nvPr/>
         </p:nvSpPr>
@@ -15200,7 +15235,7 @@
       </p:sp>
       <p:sp>
         <p:nvSpPr>
-          <p:cNvPr id="9" name="Shape 6"/>
+          <p:cNvPr id="10" name="Shape 6"/>
           <p:cNvSpPr/>
           <p:nvPr/>
         </p:nvSpPr>
@@ -15222,7 +15257,7 @@
       </p:sp>
       <p:sp>
         <p:nvSpPr>
-          <p:cNvPr id="10" name="Text 7"/>
+          <p:cNvPr id="11" name="Text 7"/>
           <p:cNvSpPr/>
           <p:nvPr/>
         </p:nvSpPr>
@@ -15261,7 +15296,7 @@
       </p:sp>
       <p:sp>
         <p:nvSpPr>
-          <p:cNvPr id="11" name="Text 8"/>
+          <p:cNvPr id="12" name="Text 8"/>
           <p:cNvSpPr/>
           <p:nvPr/>
         </p:nvSpPr>
@@ -15300,7 +15335,7 @@
       </p:sp>
       <p:sp>
         <p:nvSpPr>
-          <p:cNvPr id="12" name="Shape 9"/>
+          <p:cNvPr id="13" name="Shape 9"/>
           <p:cNvSpPr/>
           <p:nvPr/>
         </p:nvSpPr>
@@ -15322,7 +15357,7 @@
       </p:sp>
       <p:sp>
         <p:nvSpPr>
-          <p:cNvPr id="13" name="Text 10"/>
+          <p:cNvPr id="14" name="Text 10"/>
           <p:cNvSpPr/>
           <p:nvPr/>
         </p:nvSpPr>
@@ -15361,7 +15396,7 @@
       </p:sp>
       <p:sp>
         <p:nvSpPr>
-          <p:cNvPr id="14" name="Text 11"/>
+          <p:cNvPr id="15" name="Text 11"/>
           <p:cNvSpPr/>
           <p:nvPr/>
         </p:nvSpPr>
@@ -15400,7 +15435,7 @@
       </p:sp>
       <p:sp>
         <p:nvSpPr>
-          <p:cNvPr id="15" name="Shape 12"/>
+          <p:cNvPr id="16" name="Shape 12"/>
           <p:cNvSpPr/>
           <p:nvPr/>
         </p:nvSpPr>
@@ -15422,7 +15457,7 @@
       </p:sp>
       <p:sp>
         <p:nvSpPr>
-          <p:cNvPr id="16" name="Text 13"/>
+          <p:cNvPr id="17" name="Text 13"/>
           <p:cNvSpPr/>
           <p:nvPr/>
         </p:nvSpPr>
@@ -15461,7 +15496,7 @@
       </p:sp>
       <p:sp>
         <p:nvSpPr>
-          <p:cNvPr id="17" name="Text 14"/>
+          <p:cNvPr id="18" name="Text 14"/>
           <p:cNvSpPr/>
           <p:nvPr/>
         </p:nvSpPr>
@@ -15500,7 +15535,7 @@
       </p:sp>
       <p:sp>
         <p:nvSpPr>
-          <p:cNvPr id="18" name="Shape 15"/>
+          <p:cNvPr id="19" name="Shape 15"/>
           <p:cNvSpPr/>
           <p:nvPr/>
         </p:nvSpPr>
@@ -15522,7 +15557,7 @@
       </p:sp>
       <p:sp>
         <p:nvSpPr>
-          <p:cNvPr id="19" name="Text 16"/>
+          <p:cNvPr id="20" name="Text 16"/>
           <p:cNvSpPr/>
           <p:nvPr/>
         </p:nvSpPr>
@@ -15561,7 +15596,7 @@
       </p:sp>
       <p:sp>
         <p:nvSpPr>
-          <p:cNvPr id="20" name="Text 17"/>
+          <p:cNvPr id="21" name="Text 17"/>
           <p:cNvSpPr/>
           <p:nvPr/>
         </p:nvSpPr>
@@ -15600,7 +15635,7 @@
       </p:sp>
       <p:sp>
         <p:nvSpPr>
-          <p:cNvPr id="21" name="Shape 18"/>
+          <p:cNvPr id="22" name="Shape 18"/>
           <p:cNvSpPr/>
           <p:nvPr/>
         </p:nvSpPr>
@@ -15622,7 +15657,7 @@
       </p:sp>
       <p:sp>
         <p:nvSpPr>
-          <p:cNvPr id="22" name="Text 19"/>
+          <p:cNvPr id="23" name="Text 19"/>
           <p:cNvSpPr/>
           <p:nvPr/>
         </p:nvSpPr>
@@ -15661,7 +15696,7 @@
       </p:sp>
       <p:sp>
         <p:nvSpPr>
-          <p:cNvPr id="23" name="Text 20"/>
+          <p:cNvPr id="24" name="Text 20"/>
           <p:cNvSpPr/>
           <p:nvPr/>
         </p:nvSpPr>
@@ -15700,7 +15735,7 @@
       </p:sp>
       <p:sp>
         <p:nvSpPr>
-          <p:cNvPr id="24" name="Text 21"/>
+          <p:cNvPr id="25" name="Text 21"/>
           <p:cNvSpPr/>
           <p:nvPr/>
         </p:nvSpPr>
@@ -15739,7 +15774,7 @@
       </p:sp>
       <p:sp>
         <p:nvSpPr>
-          <p:cNvPr id="25" name="Text 22"/>
+          <p:cNvPr id="26" name="Text 22"/>
           <p:cNvSpPr/>
           <p:nvPr/>
         </p:nvSpPr>
@@ -15928,7 +15963,7 @@
       </p:sp>
       <p:sp>
         <p:nvSpPr>
-          <p:cNvPr id="6" name="Shape 4"/>
+          <p:cNvPr id="7" name="Shape 4"/>
           <p:cNvSpPr/>
           <p:nvPr/>
         </p:nvSpPr>
@@ -15960,7 +15995,7 @@
       </p:sp>
       <p:sp>
         <p:nvSpPr>
-          <p:cNvPr id="7" name="Text 5"/>
+          <p:cNvPr id="8" name="Text 5"/>
           <p:cNvSpPr/>
           <p:nvPr/>
         </p:nvSpPr>
@@ -15999,7 +16034,7 @@
       </p:sp>
       <p:sp>
         <p:nvSpPr>
-          <p:cNvPr id="8" name="Shape 6"/>
+          <p:cNvPr id="9" name="Shape 6"/>
           <p:cNvSpPr/>
           <p:nvPr/>
         </p:nvSpPr>
@@ -16024,7 +16059,7 @@
       </p:sp>
       <p:sp>
         <p:nvSpPr>
-          <p:cNvPr id="9" name="Shape 7"/>
+          <p:cNvPr id="10" name="Shape 7"/>
           <p:cNvSpPr/>
           <p:nvPr/>
         </p:nvSpPr>
@@ -16044,7 +16079,7 @@
       </p:sp>
       <p:sp>
         <p:nvSpPr>
-          <p:cNvPr id="10" name="Text 8"/>
+          <p:cNvPr id="11" name="Text 8"/>
           <p:cNvSpPr/>
           <p:nvPr/>
         </p:nvSpPr>
@@ -16083,7 +16118,7 @@
       </p:sp>
       <p:sp>
         <p:nvSpPr>
-          <p:cNvPr id="11" name="Text 9"/>
+          <p:cNvPr id="12" name="Text 9"/>
           <p:cNvSpPr/>
           <p:nvPr/>
         </p:nvSpPr>
@@ -16122,7 +16157,7 @@
       </p:sp>
       <p:sp>
         <p:nvSpPr>
-          <p:cNvPr id="12" name="Shape 10"/>
+          <p:cNvPr id="13" name="Shape 10"/>
           <p:cNvSpPr/>
           <p:nvPr/>
         </p:nvSpPr>
@@ -16147,7 +16182,7 @@
       </p:sp>
       <p:sp>
         <p:nvSpPr>
-          <p:cNvPr id="13" name="Shape 11"/>
+          <p:cNvPr id="14" name="Shape 11"/>
           <p:cNvSpPr/>
           <p:nvPr/>
         </p:nvSpPr>
@@ -16167,7 +16202,7 @@
       </p:sp>
       <p:sp>
         <p:nvSpPr>
-          <p:cNvPr id="14" name="Text 12"/>
+          <p:cNvPr id="15" name="Text 12"/>
           <p:cNvSpPr/>
           <p:nvPr/>
         </p:nvSpPr>
@@ -16206,7 +16241,7 @@
       </p:sp>
       <p:sp>
         <p:nvSpPr>
-          <p:cNvPr id="15" name="Text 13"/>
+          <p:cNvPr id="16" name="Text 13"/>
           <p:cNvSpPr/>
           <p:nvPr/>
         </p:nvSpPr>
@@ -16245,7 +16280,7 @@
       </p:sp>
       <p:sp>
         <p:nvSpPr>
-          <p:cNvPr id="16" name="Shape 14"/>
+          <p:cNvPr id="17" name="Shape 14"/>
           <p:cNvSpPr/>
           <p:nvPr/>
         </p:nvSpPr>
@@ -16270,7 +16305,7 @@
       </p:sp>
       <p:sp>
         <p:nvSpPr>
-          <p:cNvPr id="17" name="Shape 15"/>
+          <p:cNvPr id="18" name="Shape 15"/>
           <p:cNvSpPr/>
           <p:nvPr/>
         </p:nvSpPr>
@@ -16290,7 +16325,7 @@
       </p:sp>
       <p:sp>
         <p:nvSpPr>
-          <p:cNvPr id="18" name="Text 16"/>
+          <p:cNvPr id="19" name="Text 16"/>
           <p:cNvSpPr/>
           <p:nvPr/>
         </p:nvSpPr>
@@ -16329,7 +16364,7 @@
       </p:sp>
       <p:sp>
         <p:nvSpPr>
-          <p:cNvPr id="19" name="Text 17"/>
+          <p:cNvPr id="20" name="Text 17"/>
           <p:cNvSpPr/>
           <p:nvPr/>
         </p:nvSpPr>
@@ -16368,7 +16403,7 @@
       </p:sp>
       <p:sp>
         <p:nvSpPr>
-          <p:cNvPr id="20" name="Shape 18"/>
+          <p:cNvPr id="21" name="Shape 18"/>
           <p:cNvSpPr/>
           <p:nvPr/>
         </p:nvSpPr>
@@ -16400,7 +16435,7 @@
       </p:sp>
       <p:sp>
         <p:nvSpPr>
-          <p:cNvPr id="21" name="Text 19"/>
+          <p:cNvPr id="22" name="Text 19"/>
           <p:cNvSpPr/>
           <p:nvPr/>
         </p:nvSpPr>
@@ -16439,7 +16474,7 @@
       </p:sp>
       <p:sp>
         <p:nvSpPr>
-          <p:cNvPr id="22" name="Shape 20"/>
+          <p:cNvPr id="23" name="Shape 20"/>
           <p:cNvSpPr/>
           <p:nvPr/>
         </p:nvSpPr>
@@ -16459,7 +16494,7 @@
       </p:sp>
       <p:sp>
         <p:nvSpPr>
-          <p:cNvPr id="23" name="Text 21"/>
+          <p:cNvPr id="24" name="Text 21"/>
           <p:cNvSpPr/>
           <p:nvPr/>
         </p:nvSpPr>
@@ -16549,7 +16584,7 @@
       </p:sp>
       <p:sp>
         <p:nvSpPr>
-          <p:cNvPr id="24" name="Text 22"/>
+          <p:cNvPr id="25" name="Text 22"/>
           <p:cNvSpPr/>
           <p:nvPr/>
         </p:nvSpPr>
@@ -16613,7 +16648,7 @@
       </p:sp>
       <p:sp>
         <p:nvSpPr>
-          <p:cNvPr id="25" name="Shape 23"/>
+          <p:cNvPr id="26" name="Shape 23"/>
           <p:cNvSpPr/>
           <p:nvPr/>
         </p:nvSpPr>
@@ -16645,7 +16680,7 @@
       </p:sp>
       <p:sp>
         <p:nvSpPr>
-          <p:cNvPr id="26" name="Text 24"/>
+          <p:cNvPr id="27" name="Text 24"/>
           <p:cNvSpPr/>
           <p:nvPr/>
         </p:nvSpPr>
@@ -16684,7 +16719,7 @@
       </p:sp>
       <p:sp>
         <p:nvSpPr>
-          <p:cNvPr id="27" name="Shape 25"/>
+          <p:cNvPr id="28" name="Shape 25"/>
           <p:cNvSpPr/>
           <p:nvPr/>
         </p:nvSpPr>
@@ -16704,7 +16739,7 @@
       </p:sp>
       <p:sp>
         <p:nvSpPr>
-          <p:cNvPr id="28" name="Text 26"/>
+          <p:cNvPr id="29" name="Text 26"/>
           <p:cNvSpPr/>
           <p:nvPr/>
         </p:nvSpPr>
@@ -16786,7 +16821,7 @@
       </p:sp>
       <p:sp>
         <p:nvSpPr>
-          <p:cNvPr id="29" name="Text 27"/>
+          <p:cNvPr id="30" name="Text 27"/>
           <p:cNvSpPr/>
           <p:nvPr/>
         </p:nvSpPr>
@@ -16825,7 +16860,7 @@
       </p:sp>
       <p:sp>
         <p:nvSpPr>
-          <p:cNvPr id="30" name="Text 28"/>
+          <p:cNvPr id="31" name="Text 28"/>
           <p:cNvSpPr/>
           <p:nvPr/>
         </p:nvSpPr>

</xml_diff>